<commit_message>
docs(deck): add report/diff sample views to executive deck
Make the executive deck concrete with faithful reproductions of the actual views:
- "Proof it was tested" slide is now a sample Release Test Report summary — a
  framed document with a stat band (total / passed / not-tested / issues) and the
  per-module coverage matrix with a colour-coded Ready / Review / At-risk Status
  column, exactly as the PDF report presents it.
- "Compare releases" slide gains a sample changed-API card — Changed badge,
  version bump, backend service-version change, and a payload +/- delta — mirroring
  the release-impact diff view.

Both marked "Sample". Rendered via LibreOffice to verify layout.

Co-Authored-By: Claude Opus 4.8 (1M context) <noreply@anthropic.com>
</commit_message>
<xml_diff>
--- a/docs/TraceGuard-Executive.pptx
+++ b/docs/TraceGuard-Executive.pptx
@@ -5077,7 +5077,7 @@
         <p:spPr>
           <a:xfrm>
             <a:off x="566928" y="2697480"/>
-            <a:ext cx="10972800" cy="502920"/>
+            <a:ext cx="5806440" cy="548640"/>
           </a:xfrm>
           <a:prstGeom prst="rect">
             <a:avLst/>
@@ -5093,7 +5093,7 @@
               <a:buNone/>
             </a:pPr>
             <a:r>
-              <a:rPr lang="en-US" sz="1500" b="1" dirty="0">
+              <a:rPr lang="en-US" sz="1450" b="1" dirty="0">
                 <a:solidFill>
                   <a:srgbClr val="2563EB"/>
                 </a:solidFill>
@@ -5107,7 +5107,7 @@
               <a:buNone/>
             </a:pPr>
             <a:r>
-              <a:rPr lang="en-US" sz="1500" dirty="0">
+              <a:rPr lang="en-US" sz="1450" dirty="0">
                 <a:solidFill>
                   <a:srgbClr val="5B6B85"/>
                 </a:solidFill>
@@ -5117,7 +5117,7 @@
               </a:rPr>
               <a:t>Per API, see exactly what changed since the previous release.</a:t>
             </a:r>
-            <a:endParaRPr lang="en-US" sz="1500" dirty="0"/>
+            <a:endParaRPr lang="en-US" sz="1450" dirty="0"/>
           </a:p>
         </p:txBody>
       </p:sp>
@@ -5129,8 +5129,8 @@
         </p:nvSpPr>
         <p:spPr>
           <a:xfrm>
-            <a:off x="566928" y="3337560"/>
-            <a:ext cx="10972800" cy="502920"/>
+            <a:off x="566928" y="3355848"/>
+            <a:ext cx="5806440" cy="548640"/>
           </a:xfrm>
           <a:prstGeom prst="rect">
             <a:avLst/>
@@ -5146,7 +5146,7 @@
               <a:buNone/>
             </a:pPr>
             <a:r>
-              <a:rPr lang="en-US" sz="1500" b="1" dirty="0">
+              <a:rPr lang="en-US" sz="1450" b="1" dirty="0">
                 <a:solidFill>
                   <a:srgbClr val="2563EB"/>
                 </a:solidFill>
@@ -5160,7 +5160,7 @@
               <a:buNone/>
             </a:pPr>
             <a:r>
-              <a:rPr lang="en-US" sz="1500" dirty="0">
+              <a:rPr lang="en-US" sz="1450" dirty="0">
                 <a:solidFill>
                   <a:srgbClr val="5B6B85"/>
                 </a:solidFill>
@@ -5170,7 +5170,7 @@
               </a:rPr>
               <a:t>New and Changed are highlighted — so QA targets only what needs testing.</a:t>
             </a:r>
-            <a:endParaRPr lang="en-US" sz="1500" dirty="0"/>
+            <a:endParaRPr lang="en-US" sz="1450" dirty="0"/>
           </a:p>
         </p:txBody>
       </p:sp>
@@ -5182,8 +5182,8 @@
         </p:nvSpPr>
         <p:spPr>
           <a:xfrm>
-            <a:off x="566928" y="3977640"/>
-            <a:ext cx="10972800" cy="502920"/>
+            <a:off x="566928" y="4014216"/>
+            <a:ext cx="5806440" cy="548640"/>
           </a:xfrm>
           <a:prstGeom prst="rect">
             <a:avLst/>
@@ -5199,7 +5199,7 @@
               <a:buNone/>
             </a:pPr>
             <a:r>
-              <a:rPr lang="en-US" sz="1500" b="1" dirty="0">
+              <a:rPr lang="en-US" sz="1450" b="1" dirty="0">
                 <a:solidFill>
                   <a:srgbClr val="2563EB"/>
                 </a:solidFill>
@@ -5213,7 +5213,7 @@
               <a:buNone/>
             </a:pPr>
             <a:r>
-              <a:rPr lang="en-US" sz="1500" dirty="0">
+              <a:rPr lang="en-US" sz="1450" dirty="0">
                 <a:solidFill>
                   <a:srgbClr val="5B6B85"/>
                 </a:solidFill>
@@ -5223,7 +5223,7 @@
               </a:rPr>
               <a:t>Payload changes — request fields added or removed — are surfaced automatically.</a:t>
             </a:r>
-            <a:endParaRPr lang="en-US" sz="1500" dirty="0"/>
+            <a:endParaRPr lang="en-US" sz="1450" dirty="0"/>
           </a:p>
         </p:txBody>
       </p:sp>
@@ -5235,8 +5235,8 @@
         </p:nvSpPr>
         <p:spPr>
           <a:xfrm>
-            <a:off x="566928" y="4617720"/>
-            <a:ext cx="10972800" cy="502920"/>
+            <a:off x="566928" y="4672584"/>
+            <a:ext cx="5806440" cy="548640"/>
           </a:xfrm>
           <a:prstGeom prst="rect">
             <a:avLst/>
@@ -5252,7 +5252,7 @@
               <a:buNone/>
             </a:pPr>
             <a:r>
-              <a:rPr lang="en-US" sz="1500" b="1" dirty="0">
+              <a:rPr lang="en-US" sz="1450" b="1" dirty="0">
                 <a:solidFill>
                   <a:srgbClr val="2563EB"/>
                 </a:solidFill>
@@ -5266,7 +5266,7 @@
               <a:buNone/>
             </a:pPr>
             <a:r>
-              <a:rPr lang="en-US" sz="1500" dirty="0">
+              <a:rPr lang="en-US" sz="1450" dirty="0">
                 <a:solidFill>
                   <a:srgbClr val="5B6B85"/>
                 </a:solidFill>
@@ -5276,7 +5276,364 @@
               </a:rPr>
               <a:t>An element-level view shows precisely what differs, not just that it differs.</a:t>
             </a:r>
-            <a:endParaRPr lang="en-US" sz="1500" dirty="0"/>
+            <a:endParaRPr lang="en-US" sz="1450" dirty="0"/>
+          </a:p>
+        </p:txBody>
+      </p:sp>
+      <p:sp>
+        <p:nvSpPr>
+          <p:cNvPr id="14" name="Shape 12"/>
+          <p:cNvSpPr/>
+          <p:nvPr/>
+        </p:nvSpPr>
+        <p:spPr>
+          <a:xfrm>
+            <a:off x="6720840" y="2468880"/>
+            <a:ext cx="4901184" cy="2514600"/>
+          </a:xfrm>
+          <a:prstGeom prst="roundRect">
+            <a:avLst>
+              <a:gd name="adj" fmla="val 2182"/>
+            </a:avLst>
+          </a:prstGeom>
+          <a:solidFill>
+            <a:srgbClr val="FFFFFF"/>
+          </a:solidFill>
+          <a:ln w="12700">
+            <a:solidFill>
+              <a:srgbClr val="D7E0EE"/>
+            </a:solidFill>
+            <a:prstDash val="solid"/>
+          </a:ln>
+          <a:effectLst>
+            <a:outerShdw sx="100000" sy="100000" kx="0" ky="0" algn="bl" rotWithShape="0" blurRad="152400" dist="25400" dir="5400000">
+              <a:srgbClr val="0B1020">
+                <a:alpha val="9000"/>
+              </a:srgbClr>
+            </a:outerShdw>
+          </a:effectLst>
+        </p:spPr>
+      </p:sp>
+      <p:sp>
+        <p:nvSpPr>
+          <p:cNvPr id="15" name="Text 13"/>
+          <p:cNvSpPr/>
+          <p:nvPr/>
+        </p:nvSpPr>
+        <p:spPr>
+          <a:xfrm>
+            <a:off x="7013448" y="2706624"/>
+            <a:ext cx="2980944" cy="320040"/>
+          </a:xfrm>
+          <a:prstGeom prst="rect">
+            <a:avLst/>
+          </a:prstGeom>
+          <a:noFill/>
+          <a:ln/>
+        </p:spPr>
+        <p:txBody>
+          <a:bodyPr wrap="square" rtlCol="0" anchor="ctr"/>
+          <a:lstStyle/>
+          <a:p>
+            <a:pPr indent="0" marL="0">
+              <a:buNone/>
+            </a:pPr>
+            <a:r>
+              <a:rPr lang="en-US" sz="1400" b="1" dirty="0">
+                <a:solidFill>
+                  <a:srgbClr val="17233B"/>
+                </a:solidFill>
+                <a:latin typeface="Calibri" pitchFamily="34" charset="0"/>
+                <a:ea typeface="Calibri" pitchFamily="34" charset="-122"/>
+                <a:cs typeface="Calibri" pitchFamily="34" charset="-120"/>
+              </a:rPr>
+              <a:t>POST /transfer/submit</a:t>
+            </a:r>
+            <a:endParaRPr lang="en-US" sz="1400" dirty="0"/>
+          </a:p>
+        </p:txBody>
+      </p:sp>
+      <p:sp>
+        <p:nvSpPr>
+          <p:cNvPr id="16" name="Text 14"/>
+          <p:cNvSpPr/>
+          <p:nvPr/>
+        </p:nvSpPr>
+        <p:spPr>
+          <a:xfrm>
+            <a:off x="9930384" y="2743200"/>
+            <a:ext cx="1417320" cy="274320"/>
+          </a:xfrm>
+          <a:prstGeom prst="rect">
+            <a:avLst/>
+          </a:prstGeom>
+          <a:noFill/>
+          <a:ln/>
+        </p:spPr>
+        <p:txBody>
+          <a:bodyPr wrap="square" rtlCol="0" anchor="ctr"/>
+          <a:lstStyle/>
+          <a:p>
+            <a:pPr algn="r" indent="0" marL="0">
+              <a:buNone/>
+            </a:pPr>
+            <a:r>
+              <a:rPr lang="en-US" sz="1100" dirty="0">
+                <a:solidFill>
+                  <a:srgbClr val="64748B"/>
+                </a:solidFill>
+                <a:latin typeface="Calibri" pitchFamily="34" charset="0"/>
+                <a:ea typeface="Calibri" pitchFamily="34" charset="-122"/>
+                <a:cs typeface="Calibri" pitchFamily="34" charset="-120"/>
+              </a:rPr>
+              <a:t>9.14 → 9.18</a:t>
+            </a:r>
+            <a:endParaRPr lang="en-US" sz="1100" dirty="0"/>
+          </a:p>
+        </p:txBody>
+      </p:sp>
+      <p:sp>
+        <p:nvSpPr>
+          <p:cNvPr id="17" name="Shape 15"/>
+          <p:cNvSpPr/>
+          <p:nvPr/>
+        </p:nvSpPr>
+        <p:spPr>
+          <a:xfrm>
+            <a:off x="7013448" y="3127248"/>
+            <a:ext cx="992124" cy="384048"/>
+          </a:xfrm>
+          <a:prstGeom prst="roundRect">
+            <a:avLst>
+              <a:gd name="adj" fmla="val 50000"/>
+            </a:avLst>
+          </a:prstGeom>
+          <a:solidFill>
+            <a:srgbClr val="FEF3C7"/>
+          </a:solidFill>
+          <a:ln/>
+        </p:spPr>
+      </p:sp>
+      <p:sp>
+        <p:nvSpPr>
+          <p:cNvPr id="18" name="Text 16"/>
+          <p:cNvSpPr/>
+          <p:nvPr/>
+        </p:nvSpPr>
+        <p:spPr>
+          <a:xfrm>
+            <a:off x="7013448" y="3127248"/>
+            <a:ext cx="992124" cy="384048"/>
+          </a:xfrm>
+          <a:prstGeom prst="rect">
+            <a:avLst/>
+          </a:prstGeom>
+          <a:noFill/>
+          <a:ln/>
+        </p:spPr>
+        <p:txBody>
+          <a:bodyPr wrap="square" rtlCol="0" anchor="ctr"/>
+          <a:lstStyle/>
+          <a:p>
+            <a:pPr algn="ctr" indent="0" marL="0">
+              <a:buNone/>
+            </a:pPr>
+            <a:r>
+              <a:rPr lang="en-US" sz="1300" b="1" dirty="0">
+                <a:solidFill>
+                  <a:srgbClr val="B45309"/>
+                </a:solidFill>
+                <a:latin typeface="Calibri" pitchFamily="34" charset="0"/>
+                <a:ea typeface="Calibri" pitchFamily="34" charset="-122"/>
+                <a:cs typeface="Calibri" pitchFamily="34" charset="-120"/>
+              </a:rPr>
+              <a:t>Changed</a:t>
+            </a:r>
+            <a:endParaRPr lang="en-US" sz="1300" dirty="0"/>
+          </a:p>
+        </p:txBody>
+      </p:sp>
+      <p:sp>
+        <p:nvSpPr>
+          <p:cNvPr id="19" name="Text 17"/>
+          <p:cNvSpPr/>
+          <p:nvPr/>
+        </p:nvSpPr>
+        <p:spPr>
+          <a:xfrm>
+            <a:off x="7031736" y="3657600"/>
+            <a:ext cx="4352544" cy="274320"/>
+          </a:xfrm>
+          <a:prstGeom prst="rect">
+            <a:avLst/>
+          </a:prstGeom>
+          <a:noFill/>
+          <a:ln/>
+        </p:spPr>
+        <p:txBody>
+          <a:bodyPr wrap="square" rtlCol="0" anchor="ctr"/>
+          <a:lstStyle/>
+          <a:p>
+            <a:pPr indent="0" marL="0">
+              <a:buNone/>
+            </a:pPr>
+            <a:r>
+              <a:rPr lang="en-US" sz="1250" dirty="0">
+                <a:solidFill>
+                  <a:srgbClr val="B45309"/>
+                </a:solidFill>
+                <a:latin typeface="Calibri" pitchFamily="34" charset="0"/>
+                <a:ea typeface="Calibri" pitchFamily="34" charset="-122"/>
+                <a:cs typeface="Calibri" pitchFamily="34" charset="-120"/>
+              </a:rPr>
+              <a:t>Backend service   2.2 → 2.3</a:t>
+            </a:r>
+            <a:endParaRPr lang="en-US" sz="1250" dirty="0"/>
+          </a:p>
+        </p:txBody>
+      </p:sp>
+      <p:sp>
+        <p:nvSpPr>
+          <p:cNvPr id="20" name="Text 18"/>
+          <p:cNvSpPr/>
+          <p:nvPr/>
+        </p:nvSpPr>
+        <p:spPr>
+          <a:xfrm>
+            <a:off x="7031736" y="4041648"/>
+            <a:ext cx="1828800" cy="256032"/>
+          </a:xfrm>
+          <a:prstGeom prst="rect">
+            <a:avLst/>
+          </a:prstGeom>
+          <a:noFill/>
+          <a:ln/>
+        </p:spPr>
+        <p:txBody>
+          <a:bodyPr wrap="square" rtlCol="0" anchor="ctr"/>
+          <a:lstStyle/>
+          <a:p>
+            <a:pPr indent="0" marL="0">
+              <a:buNone/>
+            </a:pPr>
+            <a:r>
+              <a:rPr lang="en-US" sz="1150" b="1" dirty="0">
+                <a:solidFill>
+                  <a:srgbClr val="17233B"/>
+                </a:solidFill>
+                <a:latin typeface="Calibri" pitchFamily="34" charset="0"/>
+                <a:ea typeface="Calibri" pitchFamily="34" charset="-122"/>
+                <a:cs typeface="Calibri" pitchFamily="34" charset="-120"/>
+              </a:rPr>
+              <a:t>Payload</a:t>
+            </a:r>
+            <a:endParaRPr lang="en-US" sz="1150" dirty="0"/>
+          </a:p>
+        </p:txBody>
+      </p:sp>
+      <p:sp>
+        <p:nvSpPr>
+          <p:cNvPr id="21" name="Text 19"/>
+          <p:cNvSpPr/>
+          <p:nvPr/>
+        </p:nvSpPr>
+        <p:spPr>
+          <a:xfrm>
+            <a:off x="7031736" y="4315968"/>
+            <a:ext cx="4352544" cy="274320"/>
+          </a:xfrm>
+          <a:prstGeom prst="rect">
+            <a:avLst/>
+          </a:prstGeom>
+          <a:noFill/>
+          <a:ln/>
+        </p:spPr>
+        <p:txBody>
+          <a:bodyPr wrap="square" rtlCol="0" anchor="ctr"/>
+          <a:lstStyle/>
+          <a:p>
+            <a:pPr indent="0" marL="0">
+              <a:buNone/>
+            </a:pPr>
+            <a:r>
+              <a:rPr lang="en-US" sz="1250" b="1" dirty="0">
+                <a:solidFill>
+                  <a:srgbClr val="16A34A"/>
+                </a:solidFill>
+                <a:latin typeface="Calibri" pitchFamily="34" charset="0"/>
+                <a:ea typeface="Calibri" pitchFamily="34" charset="-122"/>
+                <a:cs typeface="Calibri" pitchFamily="34" charset="-120"/>
+              </a:rPr>
+              <a:t>+ feeCode</a:t>
+            </a:r>
+            <a:pPr indent="0" marL="0">
+              <a:buNone/>
+            </a:pPr>
+            <a:r>
+              <a:rPr lang="en-US" sz="1250" dirty="0">
+                <a:solidFill>
+                  <a:srgbClr val="000000"/>
+                </a:solidFill>
+                <a:latin typeface="Calibri" pitchFamily="34" charset="0"/>
+                <a:ea typeface="Calibri" pitchFamily="34" charset="-122"/>
+                <a:cs typeface="Calibri" pitchFamily="34" charset="-120"/>
+              </a:rPr>
+              <a:t>        </a:t>
+            </a:r>
+            <a:pPr indent="0" marL="0">
+              <a:buNone/>
+            </a:pPr>
+            <a:r>
+              <a:rPr lang="en-US" sz="1250" b="1" dirty="0">
+                <a:solidFill>
+                  <a:srgbClr val="B91C1C"/>
+                </a:solidFill>
+                <a:latin typeface="Calibri" pitchFamily="34" charset="0"/>
+                <a:ea typeface="Calibri" pitchFamily="34" charset="-122"/>
+                <a:cs typeface="Calibri" pitchFamily="34" charset="-120"/>
+              </a:rPr>
+              <a:t>− legacyRef</a:t>
+            </a:r>
+            <a:endParaRPr lang="en-US" sz="1250" dirty="0"/>
+          </a:p>
+        </p:txBody>
+      </p:sp>
+      <p:sp>
+        <p:nvSpPr>
+          <p:cNvPr id="22" name="Text 20"/>
+          <p:cNvSpPr/>
+          <p:nvPr/>
+        </p:nvSpPr>
+        <p:spPr>
+          <a:xfrm>
+            <a:off x="10433304" y="4709160"/>
+            <a:ext cx="914400" cy="219456"/>
+          </a:xfrm>
+          <a:prstGeom prst="rect">
+            <a:avLst/>
+          </a:prstGeom>
+          <a:noFill/>
+          <a:ln/>
+        </p:spPr>
+        <p:txBody>
+          <a:bodyPr wrap="square" rtlCol="0" anchor="ctr"/>
+          <a:lstStyle/>
+          <a:p>
+            <a:pPr algn="r" indent="0" marL="0">
+              <a:buNone/>
+            </a:pPr>
+            <a:r>
+              <a:rPr lang="en-US" sz="900" i="1" dirty="0">
+                <a:solidFill>
+                  <a:srgbClr val="9AA5B5"/>
+                </a:solidFill>
+                <a:latin typeface="Calibri" pitchFamily="34" charset="0"/>
+                <a:ea typeface="Calibri" pitchFamily="34" charset="-122"/>
+                <a:cs typeface="Calibri" pitchFamily="34" charset="-120"/>
+              </a:rPr>
+              <a:t>Sample</a:t>
+            </a:r>
+            <a:endParaRPr lang="en-US" sz="900" dirty="0"/>
           </a:p>
         </p:txBody>
       </p:sp>
@@ -5669,7 +6026,7 @@
                 <a:ea typeface="Calibri" pitchFamily="34" charset="-122"/>
                 <a:cs typeface="Calibri" pitchFamily="34" charset="-120"/>
               </a:rPr>
-              <a:t>ONE REPORT, EVERY MODULE</a:t>
+              <a:t>PROOF IT WAS TESTED</a:t>
             </a:r>
             <a:endParaRPr lang="en-US" sz="1200" dirty="0"/>
           </a:p>
@@ -5708,7 +6065,7 @@
                 <a:ea typeface="Calibri" pitchFamily="34" charset="-122"/>
                 <a:cs typeface="Calibri" pitchFamily="34" charset="-120"/>
               </a:rPr>
-              <a:t>Proof the whole release was tested</a:t>
+              <a:t>One report validates the whole release was tested</a:t>
             </a:r>
             <a:endParaRPr lang="en-US" sz="3000" dirty="0"/>
           </a:p>
@@ -5722,12 +6079,12 @@
         </p:nvSpPr>
         <p:spPr>
           <a:xfrm>
-            <a:off x="566928" y="2103120"/>
-            <a:ext cx="3502152" cy="1554480"/>
+            <a:off x="566928" y="1737360"/>
+            <a:ext cx="11055096" cy="3703320"/>
           </a:xfrm>
           <a:prstGeom prst="roundRect">
             <a:avLst>
-              <a:gd name="adj" fmla="val 5294"/>
+              <a:gd name="adj" fmla="val 1235"/>
             </a:avLst>
           </a:prstGeom>
           <a:solidFill>
@@ -5739,40 +6096,125 @@
             </a:solidFill>
             <a:prstDash val="solid"/>
           </a:ln>
-        </p:spPr>
-      </p:sp>
-      <p:sp>
-        <p:nvSpPr>
-          <p:cNvPr id="5" name="Shape 3"/>
-          <p:cNvSpPr/>
-          <p:nvPr/>
-        </p:nvSpPr>
-        <p:spPr>
-          <a:xfrm>
-            <a:off x="841248" y="2331720"/>
-            <a:ext cx="800100" cy="384048"/>
+          <a:effectLst>
+            <a:outerShdw sx="100000" sy="100000" kx="0" ky="0" algn="bl" rotWithShape="0" blurRad="177800" dist="38100" dir="5400000">
+              <a:srgbClr val="0B1020">
+                <a:alpha val="10000"/>
+              </a:srgbClr>
+            </a:outerShdw>
+          </a:effectLst>
+        </p:spPr>
+      </p:sp>
+      <p:sp>
+        <p:nvSpPr>
+          <p:cNvPr id="5" name="Text 3"/>
+          <p:cNvSpPr/>
+          <p:nvPr/>
+        </p:nvSpPr>
+        <p:spPr>
+          <a:xfrm>
+            <a:off x="877824" y="1938528"/>
+            <a:ext cx="5486400" cy="320040"/>
+          </a:xfrm>
+          <a:prstGeom prst="rect">
+            <a:avLst/>
+          </a:prstGeom>
+          <a:noFill/>
+          <a:ln/>
+        </p:spPr>
+        <p:txBody>
+          <a:bodyPr wrap="square" rtlCol="0" anchor="ctr"/>
+          <a:lstStyle/>
+          <a:p>
+            <a:pPr indent="0" marL="0">
+              <a:buNone/>
+            </a:pPr>
+            <a:r>
+              <a:rPr lang="en-US" sz="1500" b="1" dirty="0">
+                <a:solidFill>
+                  <a:srgbClr val="17233B"/>
+                </a:solidFill>
+                <a:latin typeface="Calibri" pitchFamily="34" charset="0"/>
+                <a:ea typeface="Calibri" pitchFamily="34" charset="-122"/>
+                <a:cs typeface="Calibri" pitchFamily="34" charset="-120"/>
+              </a:rPr>
+              <a:t>Release Test Report</a:t>
+            </a:r>
+            <a:endParaRPr lang="en-US" sz="1500" dirty="0"/>
+          </a:p>
+        </p:txBody>
+      </p:sp>
+      <p:sp>
+        <p:nvSpPr>
+          <p:cNvPr id="6" name="Text 4"/>
+          <p:cNvSpPr/>
+          <p:nvPr/>
+        </p:nvSpPr>
+        <p:spPr>
+          <a:xfrm>
+            <a:off x="6501384" y="1984248"/>
+            <a:ext cx="4846320" cy="274320"/>
+          </a:xfrm>
+          <a:prstGeom prst="rect">
+            <a:avLst/>
+          </a:prstGeom>
+          <a:noFill/>
+          <a:ln/>
+        </p:spPr>
+        <p:txBody>
+          <a:bodyPr wrap="square" rtlCol="0" anchor="ctr"/>
+          <a:lstStyle/>
+          <a:p>
+            <a:pPr algn="r" indent="0" marL="0">
+              <a:buNone/>
+            </a:pPr>
+            <a:r>
+              <a:rPr lang="en-US" sz="1100" dirty="0">
+                <a:solidFill>
+                  <a:srgbClr val="5B6B85"/>
+                </a:solidFill>
+                <a:latin typeface="Calibri" pitchFamily="34" charset="0"/>
+                <a:ea typeface="Calibri" pitchFamily="34" charset="-122"/>
+                <a:cs typeface="Calibri" pitchFamily="34" charset="-120"/>
+              </a:rPr>
+              <a:t>Mighty  ·  release 9.18  ·  SG  ·  5 modules</a:t>
+            </a:r>
+            <a:endParaRPr lang="en-US" sz="1100" dirty="0"/>
+          </a:p>
+        </p:txBody>
+      </p:sp>
+      <p:sp>
+        <p:nvSpPr>
+          <p:cNvPr id="7" name="Shape 5"/>
+          <p:cNvSpPr/>
+          <p:nvPr/>
+        </p:nvSpPr>
+        <p:spPr>
+          <a:xfrm>
+            <a:off x="877824" y="2377440"/>
+            <a:ext cx="1417320" cy="658368"/>
           </a:xfrm>
           <a:prstGeom prst="roundRect">
             <a:avLst>
-              <a:gd name="adj" fmla="val 50000"/>
+              <a:gd name="adj" fmla="val 8333"/>
             </a:avLst>
           </a:prstGeom>
           <a:solidFill>
-            <a:srgbClr val="DCFCE7"/>
+            <a:srgbClr val="F5F8FD"/>
           </a:solidFill>
           <a:ln/>
         </p:spPr>
       </p:sp>
       <p:sp>
         <p:nvSpPr>
-          <p:cNvPr id="6" name="Text 4"/>
-          <p:cNvSpPr/>
-          <p:nvPr/>
-        </p:nvSpPr>
-        <p:spPr>
-          <a:xfrm>
-            <a:off x="841248" y="2331720"/>
-            <a:ext cx="800100" cy="384048"/>
+          <p:cNvPr id="8" name="Text 6"/>
+          <p:cNvSpPr/>
+          <p:nvPr/>
+        </p:nvSpPr>
+        <p:spPr>
+          <a:xfrm>
+            <a:off x="1024128" y="2432304"/>
+            <a:ext cx="1188720" cy="384048"/>
           </a:xfrm>
           <a:prstGeom prst="rect">
             <a:avLst/>
@@ -5784,50 +6226,50 @@
           <a:bodyPr wrap="square" rtlCol="0" anchor="ctr"/>
           <a:lstStyle/>
           <a:p>
-            <a:pPr algn="ctr" indent="0" marL="0">
-              <a:buNone/>
-            </a:pPr>
-            <a:r>
-              <a:rPr lang="en-US" sz="1300" b="1" dirty="0">
-                <a:solidFill>
-                  <a:srgbClr val="16A34A"/>
-                </a:solidFill>
-                <a:latin typeface="Calibri" pitchFamily="34" charset="0"/>
-                <a:ea typeface="Calibri" pitchFamily="34" charset="-122"/>
-                <a:cs typeface="Calibri" pitchFamily="34" charset="-120"/>
-              </a:rPr>
-              <a:t>Ready</a:t>
-            </a:r>
-            <a:endParaRPr lang="en-US" sz="1300" dirty="0"/>
-          </a:p>
-        </p:txBody>
-      </p:sp>
-      <p:sp>
-        <p:nvSpPr>
-          <p:cNvPr id="7" name="Text 5"/>
-          <p:cNvSpPr/>
-          <p:nvPr/>
-        </p:nvSpPr>
-        <p:spPr>
-          <a:xfrm>
-            <a:off x="841248" y="2880360"/>
-            <a:ext cx="2953512" cy="640080"/>
-          </a:xfrm>
-          <a:prstGeom prst="rect">
-            <a:avLst/>
-          </a:prstGeom>
-          <a:noFill/>
-          <a:ln/>
-        </p:spPr>
-        <p:txBody>
-          <a:bodyPr wrap="square" rtlCol="0" anchor="t"/>
-          <a:lstStyle/>
-          <a:p>
             <a:pPr indent="0" marL="0">
               <a:buNone/>
             </a:pPr>
             <a:r>
-              <a:rPr lang="en-US" sz="1350" dirty="0">
+              <a:rPr lang="en-US" sz="1900" b="1" dirty="0">
+                <a:solidFill>
+                  <a:srgbClr val="64748B"/>
+                </a:solidFill>
+                <a:latin typeface="Calibri" pitchFamily="34" charset="0"/>
+                <a:ea typeface="Calibri" pitchFamily="34" charset="-122"/>
+                <a:cs typeface="Calibri" pitchFamily="34" charset="-120"/>
+              </a:rPr>
+              <a:t>62</a:t>
+            </a:r>
+            <a:endParaRPr lang="en-US" sz="1900" dirty="0"/>
+          </a:p>
+        </p:txBody>
+      </p:sp>
+      <p:sp>
+        <p:nvSpPr>
+          <p:cNvPr id="9" name="Text 7"/>
+          <p:cNvSpPr/>
+          <p:nvPr/>
+        </p:nvSpPr>
+        <p:spPr>
+          <a:xfrm>
+            <a:off x="1024128" y="2779776"/>
+            <a:ext cx="1234440" cy="219456"/>
+          </a:xfrm>
+          <a:prstGeom prst="rect">
+            <a:avLst/>
+          </a:prstGeom>
+          <a:noFill/>
+          <a:ln/>
+        </p:spPr>
+        <p:txBody>
+          <a:bodyPr wrap="square" rtlCol="0" anchor="ctr"/>
+          <a:lstStyle/>
+          <a:p>
+            <a:pPr indent="0" marL="0">
+              <a:buNone/>
+            </a:pPr>
+            <a:r>
+              <a:rPr lang="en-US" sz="950" dirty="0">
                 <a:solidFill>
                   <a:srgbClr val="5B6B85"/>
                 </a:solidFill>
@@ -5835,71 +6277,144 @@
                 <a:ea typeface="Calibri" pitchFamily="34" charset="-122"/>
                 <a:cs typeface="Calibri" pitchFamily="34" charset="-120"/>
               </a:rPr>
-              <a:t>Fully tested, no issues</a:t>
-            </a:r>
-            <a:endParaRPr lang="en-US" sz="1350" dirty="0"/>
-          </a:p>
-        </p:txBody>
-      </p:sp>
-      <p:sp>
-        <p:nvSpPr>
-          <p:cNvPr id="8" name="Shape 6"/>
-          <p:cNvSpPr/>
-          <p:nvPr/>
-        </p:nvSpPr>
-        <p:spPr>
-          <a:xfrm>
-            <a:off x="4343400" y="2103120"/>
-            <a:ext cx="3502152" cy="1554480"/>
+              <a:t>Total APIs</a:t>
+            </a:r>
+            <a:endParaRPr lang="en-US" sz="950" dirty="0"/>
+          </a:p>
+        </p:txBody>
+      </p:sp>
+      <p:sp>
+        <p:nvSpPr>
+          <p:cNvPr id="10" name="Shape 8"/>
+          <p:cNvSpPr/>
+          <p:nvPr/>
+        </p:nvSpPr>
+        <p:spPr>
+          <a:xfrm>
+            <a:off x="2450592" y="2377440"/>
+            <a:ext cx="1417320" cy="658368"/>
           </a:xfrm>
           <a:prstGeom prst="roundRect">
             <a:avLst>
-              <a:gd name="adj" fmla="val 5294"/>
+              <a:gd name="adj" fmla="val 8333"/>
             </a:avLst>
           </a:prstGeom>
           <a:solidFill>
-            <a:srgbClr val="FFFFFF"/>
+            <a:srgbClr val="F5F8FD"/>
           </a:solidFill>
-          <a:ln w="12700">
-            <a:solidFill>
-              <a:srgbClr val="D7E0EE"/>
-            </a:solidFill>
-            <a:prstDash val="solid"/>
-          </a:ln>
-        </p:spPr>
-      </p:sp>
-      <p:sp>
-        <p:nvSpPr>
-          <p:cNvPr id="9" name="Shape 7"/>
-          <p:cNvSpPr/>
-          <p:nvPr/>
-        </p:nvSpPr>
-        <p:spPr>
-          <a:xfrm>
-            <a:off x="4617720" y="2331720"/>
-            <a:ext cx="896112" cy="384048"/>
+          <a:ln/>
+        </p:spPr>
+      </p:sp>
+      <p:sp>
+        <p:nvSpPr>
+          <p:cNvPr id="11" name="Text 9"/>
+          <p:cNvSpPr/>
+          <p:nvPr/>
+        </p:nvSpPr>
+        <p:spPr>
+          <a:xfrm>
+            <a:off x="2596896" y="2432304"/>
+            <a:ext cx="1188720" cy="384048"/>
+          </a:xfrm>
+          <a:prstGeom prst="rect">
+            <a:avLst/>
+          </a:prstGeom>
+          <a:noFill/>
+          <a:ln/>
+        </p:spPr>
+        <p:txBody>
+          <a:bodyPr wrap="square" rtlCol="0" anchor="ctr"/>
+          <a:lstStyle/>
+          <a:p>
+            <a:pPr indent="0" marL="0">
+              <a:buNone/>
+            </a:pPr>
+            <a:r>
+              <a:rPr lang="en-US" sz="1900" b="1" dirty="0">
+                <a:solidFill>
+                  <a:srgbClr val="16A34A"/>
+                </a:solidFill>
+                <a:latin typeface="Calibri" pitchFamily="34" charset="0"/>
+                <a:ea typeface="Calibri" pitchFamily="34" charset="-122"/>
+                <a:cs typeface="Calibri" pitchFamily="34" charset="-120"/>
+              </a:rPr>
+              <a:t>41</a:t>
+            </a:r>
+            <a:endParaRPr lang="en-US" sz="1900" dirty="0"/>
+          </a:p>
+        </p:txBody>
+      </p:sp>
+      <p:sp>
+        <p:nvSpPr>
+          <p:cNvPr id="12" name="Text 10"/>
+          <p:cNvSpPr/>
+          <p:nvPr/>
+        </p:nvSpPr>
+        <p:spPr>
+          <a:xfrm>
+            <a:off x="2596896" y="2779776"/>
+            <a:ext cx="1234440" cy="219456"/>
+          </a:xfrm>
+          <a:prstGeom prst="rect">
+            <a:avLst/>
+          </a:prstGeom>
+          <a:noFill/>
+          <a:ln/>
+        </p:spPr>
+        <p:txBody>
+          <a:bodyPr wrap="square" rtlCol="0" anchor="ctr"/>
+          <a:lstStyle/>
+          <a:p>
+            <a:pPr indent="0" marL="0">
+              <a:buNone/>
+            </a:pPr>
+            <a:r>
+              <a:rPr lang="en-US" sz="950" dirty="0">
+                <a:solidFill>
+                  <a:srgbClr val="5B6B85"/>
+                </a:solidFill>
+                <a:latin typeface="Calibri" pitchFamily="34" charset="0"/>
+                <a:ea typeface="Calibri" pitchFamily="34" charset="-122"/>
+                <a:cs typeface="Calibri" pitchFamily="34" charset="-120"/>
+              </a:rPr>
+              <a:t>Passed</a:t>
+            </a:r>
+            <a:endParaRPr lang="en-US" sz="950" dirty="0"/>
+          </a:p>
+        </p:txBody>
+      </p:sp>
+      <p:sp>
+        <p:nvSpPr>
+          <p:cNvPr id="13" name="Shape 11"/>
+          <p:cNvSpPr/>
+          <p:nvPr/>
+        </p:nvSpPr>
+        <p:spPr>
+          <a:xfrm>
+            <a:off x="4023360" y="2377440"/>
+            <a:ext cx="1417320" cy="658368"/>
           </a:xfrm>
           <a:prstGeom prst="roundRect">
             <a:avLst>
-              <a:gd name="adj" fmla="val 50000"/>
+              <a:gd name="adj" fmla="val 8333"/>
             </a:avLst>
           </a:prstGeom>
           <a:solidFill>
-            <a:srgbClr val="FEF3C7"/>
+            <a:srgbClr val="F5F8FD"/>
           </a:solidFill>
           <a:ln/>
         </p:spPr>
       </p:sp>
       <p:sp>
         <p:nvSpPr>
-          <p:cNvPr id="10" name="Text 8"/>
-          <p:cNvSpPr/>
-          <p:nvPr/>
-        </p:nvSpPr>
-        <p:spPr>
-          <a:xfrm>
-            <a:off x="4617720" y="2331720"/>
-            <a:ext cx="896112" cy="384048"/>
+          <p:cNvPr id="14" name="Text 12"/>
+          <p:cNvSpPr/>
+          <p:nvPr/>
+        </p:nvSpPr>
+        <p:spPr>
+          <a:xfrm>
+            <a:off x="4169664" y="2432304"/>
+            <a:ext cx="1188720" cy="384048"/>
           </a:xfrm>
           <a:prstGeom prst="rect">
             <a:avLst/>
@@ -5911,50 +6426,50 @@
           <a:bodyPr wrap="square" rtlCol="0" anchor="ctr"/>
           <a:lstStyle/>
           <a:p>
-            <a:pPr algn="ctr" indent="0" marL="0">
-              <a:buNone/>
-            </a:pPr>
-            <a:r>
-              <a:rPr lang="en-US" sz="1300" b="1" dirty="0">
-                <a:solidFill>
-                  <a:srgbClr val="B45309"/>
-                </a:solidFill>
-                <a:latin typeface="Calibri" pitchFamily="34" charset="0"/>
-                <a:ea typeface="Calibri" pitchFamily="34" charset="-122"/>
-                <a:cs typeface="Calibri" pitchFamily="34" charset="-120"/>
-              </a:rPr>
-              <a:t>Review</a:t>
-            </a:r>
-            <a:endParaRPr lang="en-US" sz="1300" dirty="0"/>
-          </a:p>
-        </p:txBody>
-      </p:sp>
-      <p:sp>
-        <p:nvSpPr>
-          <p:cNvPr id="11" name="Text 9"/>
-          <p:cNvSpPr/>
-          <p:nvPr/>
-        </p:nvSpPr>
-        <p:spPr>
-          <a:xfrm>
-            <a:off x="4617720" y="2880360"/>
-            <a:ext cx="2953512" cy="640080"/>
-          </a:xfrm>
-          <a:prstGeom prst="rect">
-            <a:avLst/>
-          </a:prstGeom>
-          <a:noFill/>
-          <a:ln/>
-        </p:spPr>
-        <p:txBody>
-          <a:bodyPr wrap="square" rtlCol="0" anchor="t"/>
-          <a:lstStyle/>
-          <a:p>
             <a:pPr indent="0" marL="0">
               <a:buNone/>
             </a:pPr>
             <a:r>
-              <a:rPr lang="en-US" sz="1350" dirty="0">
+              <a:rPr lang="en-US" sz="1900" b="1" dirty="0">
+                <a:solidFill>
+                  <a:srgbClr val="B91C1C"/>
+                </a:solidFill>
+                <a:latin typeface="Calibri" pitchFamily="34" charset="0"/>
+                <a:ea typeface="Calibri" pitchFamily="34" charset="-122"/>
+                <a:cs typeface="Calibri" pitchFamily="34" charset="-120"/>
+              </a:rPr>
+              <a:t>21</a:t>
+            </a:r>
+            <a:endParaRPr lang="en-US" sz="1900" dirty="0"/>
+          </a:p>
+        </p:txBody>
+      </p:sp>
+      <p:sp>
+        <p:nvSpPr>
+          <p:cNvPr id="15" name="Text 13"/>
+          <p:cNvSpPr/>
+          <p:nvPr/>
+        </p:nvSpPr>
+        <p:spPr>
+          <a:xfrm>
+            <a:off x="4169664" y="2779776"/>
+            <a:ext cx="1234440" cy="219456"/>
+          </a:xfrm>
+          <a:prstGeom prst="rect">
+            <a:avLst/>
+          </a:prstGeom>
+          <a:noFill/>
+          <a:ln/>
+        </p:spPr>
+        <p:txBody>
+          <a:bodyPr wrap="square" rtlCol="0" anchor="ctr"/>
+          <a:lstStyle/>
+          <a:p>
+            <a:pPr indent="0" marL="0">
+              <a:buNone/>
+            </a:pPr>
+            <a:r>
+              <a:rPr lang="en-US" sz="950" dirty="0">
                 <a:solidFill>
                   <a:srgbClr val="5B6B85"/>
                 </a:solidFill>
@@ -5962,71 +6477,44 @@
                 <a:ea typeface="Calibri" pitchFamily="34" charset="-122"/>
                 <a:cs typeface="Calibri" pitchFamily="34" charset="-120"/>
               </a:rPr>
-              <a:t>Untested APIs to check</a:t>
-            </a:r>
-            <a:endParaRPr lang="en-US" sz="1350" dirty="0"/>
-          </a:p>
-        </p:txBody>
-      </p:sp>
-      <p:sp>
-        <p:nvSpPr>
-          <p:cNvPr id="12" name="Shape 10"/>
-          <p:cNvSpPr/>
-          <p:nvPr/>
-        </p:nvSpPr>
-        <p:spPr>
-          <a:xfrm>
-            <a:off x="8119872" y="2103120"/>
-            <a:ext cx="3502152" cy="1554480"/>
+              <a:t>Not tested</a:t>
+            </a:r>
+            <a:endParaRPr lang="en-US" sz="950" dirty="0"/>
+          </a:p>
+        </p:txBody>
+      </p:sp>
+      <p:sp>
+        <p:nvSpPr>
+          <p:cNvPr id="16" name="Shape 14"/>
+          <p:cNvSpPr/>
+          <p:nvPr/>
+        </p:nvSpPr>
+        <p:spPr>
+          <a:xfrm>
+            <a:off x="5596128" y="2377440"/>
+            <a:ext cx="1417320" cy="658368"/>
           </a:xfrm>
           <a:prstGeom prst="roundRect">
             <a:avLst>
-              <a:gd name="adj" fmla="val 5294"/>
+              <a:gd name="adj" fmla="val 8333"/>
             </a:avLst>
           </a:prstGeom>
           <a:solidFill>
-            <a:srgbClr val="FFFFFF"/>
+            <a:srgbClr val="F5F8FD"/>
           </a:solidFill>
-          <a:ln w="12700">
-            <a:solidFill>
-              <a:srgbClr val="D7E0EE"/>
-            </a:solidFill>
-            <a:prstDash val="solid"/>
-          </a:ln>
-        </p:spPr>
-      </p:sp>
-      <p:sp>
-        <p:nvSpPr>
-          <p:cNvPr id="13" name="Shape 11"/>
-          <p:cNvSpPr/>
-          <p:nvPr/>
-        </p:nvSpPr>
-        <p:spPr>
-          <a:xfrm>
-            <a:off x="8394192" y="2331720"/>
-            <a:ext cx="992124" cy="384048"/>
-          </a:xfrm>
-          <a:prstGeom prst="roundRect">
-            <a:avLst>
-              <a:gd name="adj" fmla="val 50000"/>
-            </a:avLst>
-          </a:prstGeom>
-          <a:solidFill>
-            <a:srgbClr val="FEE2E2"/>
-          </a:solidFill>
-          <a:ln/>
-        </p:spPr>
-      </p:sp>
-      <p:sp>
-        <p:nvSpPr>
-          <p:cNvPr id="14" name="Text 12"/>
-          <p:cNvSpPr/>
-          <p:nvPr/>
-        </p:nvSpPr>
-        <p:spPr>
-          <a:xfrm>
-            <a:off x="8394192" y="2331720"/>
-            <a:ext cx="992124" cy="384048"/>
+          <a:ln/>
+        </p:spPr>
+      </p:sp>
+      <p:sp>
+        <p:nvSpPr>
+          <p:cNvPr id="17" name="Text 15"/>
+          <p:cNvSpPr/>
+          <p:nvPr/>
+        </p:nvSpPr>
+        <p:spPr>
+          <a:xfrm>
+            <a:off x="5742432" y="2432304"/>
+            <a:ext cx="1188720" cy="384048"/>
           </a:xfrm>
           <a:prstGeom prst="rect">
             <a:avLst/>
@@ -6038,50 +6526,50 @@
           <a:bodyPr wrap="square" rtlCol="0" anchor="ctr"/>
           <a:lstStyle/>
           <a:p>
-            <a:pPr algn="ctr" indent="0" marL="0">
-              <a:buNone/>
-            </a:pPr>
-            <a:r>
-              <a:rPr lang="en-US" sz="1300" b="1" dirty="0">
-                <a:solidFill>
-                  <a:srgbClr val="B91C1C"/>
-                </a:solidFill>
-                <a:latin typeface="Calibri" pitchFamily="34" charset="0"/>
-                <a:ea typeface="Calibri" pitchFamily="34" charset="-122"/>
-                <a:cs typeface="Calibri" pitchFamily="34" charset="-120"/>
-              </a:rPr>
-              <a:t>At risk</a:t>
-            </a:r>
-            <a:endParaRPr lang="en-US" sz="1300" dirty="0"/>
-          </a:p>
-        </p:txBody>
-      </p:sp>
-      <p:sp>
-        <p:nvSpPr>
-          <p:cNvPr id="15" name="Text 13"/>
-          <p:cNvSpPr/>
-          <p:nvPr/>
-        </p:nvSpPr>
-        <p:spPr>
-          <a:xfrm>
-            <a:off x="8394192" y="2880360"/>
-            <a:ext cx="2953512" cy="640080"/>
-          </a:xfrm>
-          <a:prstGeom prst="rect">
-            <a:avLst/>
-          </a:prstGeom>
-          <a:noFill/>
-          <a:ln/>
-        </p:spPr>
-        <p:txBody>
-          <a:bodyPr wrap="square" rtlCol="0" anchor="t"/>
-          <a:lstStyle/>
-          <a:p>
             <a:pPr indent="0" marL="0">
               <a:buNone/>
             </a:pPr>
             <a:r>
-              <a:rPr lang="en-US" sz="1350" dirty="0">
+              <a:rPr lang="en-US" sz="1900" b="1" dirty="0">
+                <a:solidFill>
+                  <a:srgbClr val="B45309"/>
+                </a:solidFill>
+                <a:latin typeface="Calibri" pitchFamily="34" charset="0"/>
+                <a:ea typeface="Calibri" pitchFamily="34" charset="-122"/>
+                <a:cs typeface="Calibri" pitchFamily="34" charset="-120"/>
+              </a:rPr>
+              <a:t>2</a:t>
+            </a:r>
+            <a:endParaRPr lang="en-US" sz="1900" dirty="0"/>
+          </a:p>
+        </p:txBody>
+      </p:sp>
+      <p:sp>
+        <p:nvSpPr>
+          <p:cNvPr id="18" name="Text 16"/>
+          <p:cNvSpPr/>
+          <p:nvPr/>
+        </p:nvSpPr>
+        <p:spPr>
+          <a:xfrm>
+            <a:off x="5742432" y="2779776"/>
+            <a:ext cx="1234440" cy="219456"/>
+          </a:xfrm>
+          <a:prstGeom prst="rect">
+            <a:avLst/>
+          </a:prstGeom>
+          <a:noFill/>
+          <a:ln/>
+        </p:spPr>
+        <p:txBody>
+          <a:bodyPr wrap="square" rtlCol="0" anchor="ctr"/>
+          <a:lstStyle/>
+          <a:p>
+            <a:pPr indent="0" marL="0">
+              <a:buNone/>
+            </a:pPr>
+            <a:r>
+              <a:rPr lang="en-US" sz="950" dirty="0">
                 <a:solidFill>
                   <a:srgbClr val="5B6B85"/>
                 </a:solidFill>
@@ -6089,22 +6577,2441 @@
                 <a:ea typeface="Calibri" pitchFamily="34" charset="-122"/>
                 <a:cs typeface="Calibri" pitchFamily="34" charset="-120"/>
               </a:rPr>
-              <a:t>Has failures or gaps</a:t>
-            </a:r>
-            <a:endParaRPr lang="en-US" sz="1350" dirty="0"/>
-          </a:p>
-        </p:txBody>
-      </p:sp>
-      <p:sp>
-        <p:nvSpPr>
-          <p:cNvPr id="16" name="Text 14"/>
-          <p:cNvSpPr/>
-          <p:nvPr/>
-        </p:nvSpPr>
-        <p:spPr>
-          <a:xfrm>
-            <a:off x="566928" y="3977640"/>
-            <a:ext cx="10972800" cy="457200"/>
+              <a:t>Issues</a:t>
+            </a:r>
+            <a:endParaRPr lang="en-US" sz="950" dirty="0"/>
+          </a:p>
+        </p:txBody>
+      </p:sp>
+      <p:graphicFrame>
+        <p:nvGraphicFramePr>
+          <p:cNvPr id="9" name="Table 0"/>
+          <p:cNvGraphicFramePr>
+            <a:graphicFrameLocks noGrp="1"/>
+          </p:cNvGraphicFramePr>
+          <p:nvPr>
+            <p:extLst>
+              <p:ext uri="{D42A27DB-BD31-4B8C-83A1-F6EECF244321}">
+                <p14:modId xmlns:p14="http://schemas.microsoft.com/office/powerpoint/2010/main" val="1579011935"/>
+              </p:ext>
+            </p:extLst>
+          </p:nvPr>
+        </p:nvGraphicFramePr>
+        <p:xfrm>
+          <a:off x="877824" y="3218688"/>
+          <a:ext cx="10433304" cy="914400"/>
+        </p:xfrm>
+        <a:graphic>
+          <a:graphicData uri="http://schemas.openxmlformats.org/drawingml/2006/table">
+            <a:tbl>
+              <a:tblPr/>
+              <a:tblGrid>
+                <a:gridCol w="3108960"/>
+                <a:gridCol w="1051560"/>
+                <a:gridCol w="1234440"/>
+                <a:gridCol w="1417320"/>
+                <a:gridCol w="1097280"/>
+                <a:gridCol w="2523744"/>
+              </a:tblGrid>
+              <a:tr h="329184">
+                <a:tc>
+                  <a:txBody>
+                    <a:bodyPr/>
+                    <a:lstStyle/>
+                    <a:p>
+                      <a:pPr algn="l" indent="0" marL="0">
+                        <a:buNone/>
+                      </a:pPr>
+                      <a:r>
+                        <a:rPr lang="en-US" sz="1050" b="1" dirty="0">
+                          <a:solidFill>
+                            <a:srgbClr val="475569"/>
+                          </a:solidFill>
+                          <a:latin typeface="Calibri" pitchFamily="34" charset="0"/>
+                          <a:ea typeface="Calibri" pitchFamily="34" charset="-122"/>
+                          <a:cs typeface="Calibri" pitchFamily="34" charset="-120"/>
+                        </a:rPr>
+                        <a:t>Module</a:t>
+                      </a:r>
+                      <a:endParaRPr lang="en-US" sz="1050" dirty="0">
+                        <a:latin typeface="Calibri" charset="0"/>
+                        <a:ea typeface="Calibri" charset="0"/>
+                        <a:cs typeface="Calibri" charset="0"/>
+                      </a:endParaRPr>
+                    </a:p>
+                  </a:txBody>
+                  <a:tcPr marL="91440" marR="91440" marT="45720" marB="45720" anchor="ctr">
+                    <a:lnL w="6350" cap="flat" cmpd="sng" algn="ctr">
+                      <a:solidFill>
+                        <a:srgbClr val="E9EEF5"/>
+                      </a:solidFill>
+                      <a:prstDash val="solid"/>
+                      <a:round/>
+                      <a:headEnd type="none" w="med" len="med"/>
+                      <a:tailEnd type="none" w="med" len="med"/>
+                    </a:lnL>
+                    <a:lnR w="6350" cap="flat" cmpd="sng" algn="ctr">
+                      <a:solidFill>
+                        <a:srgbClr val="E9EEF5"/>
+                      </a:solidFill>
+                      <a:prstDash val="solid"/>
+                      <a:round/>
+                      <a:headEnd type="none" w="med" len="med"/>
+                      <a:tailEnd type="none" w="med" len="med"/>
+                    </a:lnR>
+                    <a:lnT w="6350" cap="flat" cmpd="sng" algn="ctr">
+                      <a:solidFill>
+                        <a:srgbClr val="E9EEF5"/>
+                      </a:solidFill>
+                      <a:prstDash val="solid"/>
+                      <a:round/>
+                      <a:headEnd type="none" w="med" len="med"/>
+                      <a:tailEnd type="none" w="med" len="med"/>
+                    </a:lnT>
+                    <a:lnB w="6350" cap="flat" cmpd="sng" algn="ctr">
+                      <a:solidFill>
+                        <a:srgbClr val="E9EEF5"/>
+                      </a:solidFill>
+                      <a:prstDash val="solid"/>
+                      <a:round/>
+                      <a:headEnd type="none" w="med" len="med"/>
+                      <a:tailEnd type="none" w="med" len="med"/>
+                    </a:lnB>
+                    <a:solidFill>
+                      <a:srgbClr val="F1F5FB"/>
+                    </a:solidFill>
+                  </a:tcPr>
+                </a:tc>
+                <a:tc>
+                  <a:txBody>
+                    <a:bodyPr/>
+                    <a:lstStyle/>
+                    <a:p>
+                      <a:pPr algn="ctr" indent="0" marL="0">
+                        <a:buNone/>
+                      </a:pPr>
+                      <a:r>
+                        <a:rPr lang="en-US" sz="1050" b="1" dirty="0">
+                          <a:solidFill>
+                            <a:srgbClr val="475569"/>
+                          </a:solidFill>
+                          <a:latin typeface="Calibri" pitchFamily="34" charset="0"/>
+                          <a:ea typeface="Calibri" pitchFamily="34" charset="-122"/>
+                          <a:cs typeface="Calibri" pitchFamily="34" charset="-120"/>
+                        </a:rPr>
+                        <a:t>APIs</a:t>
+                      </a:r>
+                      <a:endParaRPr lang="en-US" sz="1050" dirty="0">
+                        <a:latin typeface="Calibri" charset="0"/>
+                        <a:ea typeface="Calibri" charset="0"/>
+                        <a:cs typeface="Calibri" charset="0"/>
+                      </a:endParaRPr>
+                    </a:p>
+                  </a:txBody>
+                  <a:tcPr marL="91440" marR="91440" marT="45720" marB="45720" anchor="ctr">
+                    <a:lnL w="6350" cap="flat" cmpd="sng" algn="ctr">
+                      <a:solidFill>
+                        <a:srgbClr val="E9EEF5"/>
+                      </a:solidFill>
+                      <a:prstDash val="solid"/>
+                      <a:round/>
+                      <a:headEnd type="none" w="med" len="med"/>
+                      <a:tailEnd type="none" w="med" len="med"/>
+                    </a:lnL>
+                    <a:lnR w="6350" cap="flat" cmpd="sng" algn="ctr">
+                      <a:solidFill>
+                        <a:srgbClr val="E9EEF5"/>
+                      </a:solidFill>
+                      <a:prstDash val="solid"/>
+                      <a:round/>
+                      <a:headEnd type="none" w="med" len="med"/>
+                      <a:tailEnd type="none" w="med" len="med"/>
+                    </a:lnR>
+                    <a:lnT w="6350" cap="flat" cmpd="sng" algn="ctr">
+                      <a:solidFill>
+                        <a:srgbClr val="E9EEF5"/>
+                      </a:solidFill>
+                      <a:prstDash val="solid"/>
+                      <a:round/>
+                      <a:headEnd type="none" w="med" len="med"/>
+                      <a:tailEnd type="none" w="med" len="med"/>
+                    </a:lnT>
+                    <a:lnB w="6350" cap="flat" cmpd="sng" algn="ctr">
+                      <a:solidFill>
+                        <a:srgbClr val="E9EEF5"/>
+                      </a:solidFill>
+                      <a:prstDash val="solid"/>
+                      <a:round/>
+                      <a:headEnd type="none" w="med" len="med"/>
+                      <a:tailEnd type="none" w="med" len="med"/>
+                    </a:lnB>
+                    <a:solidFill>
+                      <a:srgbClr val="F1F5FB"/>
+                    </a:solidFill>
+                  </a:tcPr>
+                </a:tc>
+                <a:tc>
+                  <a:txBody>
+                    <a:bodyPr/>
+                    <a:lstStyle/>
+                    <a:p>
+                      <a:pPr algn="ctr" indent="0" marL="0">
+                        <a:buNone/>
+                      </a:pPr>
+                      <a:r>
+                        <a:rPr lang="en-US" sz="1050" b="1" dirty="0">
+                          <a:solidFill>
+                            <a:srgbClr val="475569"/>
+                          </a:solidFill>
+                          <a:latin typeface="Calibri" pitchFamily="34" charset="0"/>
+                          <a:ea typeface="Calibri" pitchFamily="34" charset="-122"/>
+                          <a:cs typeface="Calibri" pitchFamily="34" charset="-120"/>
+                        </a:rPr>
+                        <a:t>Passed</a:t>
+                      </a:r>
+                      <a:endParaRPr lang="en-US" sz="1050" dirty="0">
+                        <a:latin typeface="Calibri" charset="0"/>
+                        <a:ea typeface="Calibri" charset="0"/>
+                        <a:cs typeface="Calibri" charset="0"/>
+                      </a:endParaRPr>
+                    </a:p>
+                  </a:txBody>
+                  <a:tcPr marL="91440" marR="91440" marT="45720" marB="45720" anchor="ctr">
+                    <a:lnL w="6350" cap="flat" cmpd="sng" algn="ctr">
+                      <a:solidFill>
+                        <a:srgbClr val="E9EEF5"/>
+                      </a:solidFill>
+                      <a:prstDash val="solid"/>
+                      <a:round/>
+                      <a:headEnd type="none" w="med" len="med"/>
+                      <a:tailEnd type="none" w="med" len="med"/>
+                    </a:lnL>
+                    <a:lnR w="6350" cap="flat" cmpd="sng" algn="ctr">
+                      <a:solidFill>
+                        <a:srgbClr val="E9EEF5"/>
+                      </a:solidFill>
+                      <a:prstDash val="solid"/>
+                      <a:round/>
+                      <a:headEnd type="none" w="med" len="med"/>
+                      <a:tailEnd type="none" w="med" len="med"/>
+                    </a:lnR>
+                    <a:lnT w="6350" cap="flat" cmpd="sng" algn="ctr">
+                      <a:solidFill>
+                        <a:srgbClr val="E9EEF5"/>
+                      </a:solidFill>
+                      <a:prstDash val="solid"/>
+                      <a:round/>
+                      <a:headEnd type="none" w="med" len="med"/>
+                      <a:tailEnd type="none" w="med" len="med"/>
+                    </a:lnT>
+                    <a:lnB w="6350" cap="flat" cmpd="sng" algn="ctr">
+                      <a:solidFill>
+                        <a:srgbClr val="E9EEF5"/>
+                      </a:solidFill>
+                      <a:prstDash val="solid"/>
+                      <a:round/>
+                      <a:headEnd type="none" w="med" len="med"/>
+                      <a:tailEnd type="none" w="med" len="med"/>
+                    </a:lnB>
+                    <a:solidFill>
+                      <a:srgbClr val="F1F5FB"/>
+                    </a:solidFill>
+                  </a:tcPr>
+                </a:tc>
+                <a:tc>
+                  <a:txBody>
+                    <a:bodyPr/>
+                    <a:lstStyle/>
+                    <a:p>
+                      <a:pPr algn="ctr" indent="0" marL="0">
+                        <a:buNone/>
+                      </a:pPr>
+                      <a:r>
+                        <a:rPr lang="en-US" sz="1050" b="1" dirty="0">
+                          <a:solidFill>
+                            <a:srgbClr val="475569"/>
+                          </a:solidFill>
+                          <a:latin typeface="Calibri" pitchFamily="34" charset="0"/>
+                          <a:ea typeface="Calibri" pitchFamily="34" charset="-122"/>
+                          <a:cs typeface="Calibri" pitchFamily="34" charset="-120"/>
+                        </a:rPr>
+                        <a:t>Not tested</a:t>
+                      </a:r>
+                      <a:endParaRPr lang="en-US" sz="1050" dirty="0">
+                        <a:latin typeface="Calibri" charset="0"/>
+                        <a:ea typeface="Calibri" charset="0"/>
+                        <a:cs typeface="Calibri" charset="0"/>
+                      </a:endParaRPr>
+                    </a:p>
+                  </a:txBody>
+                  <a:tcPr marL="91440" marR="91440" marT="45720" marB="45720" anchor="ctr">
+                    <a:lnL w="6350" cap="flat" cmpd="sng" algn="ctr">
+                      <a:solidFill>
+                        <a:srgbClr val="E9EEF5"/>
+                      </a:solidFill>
+                      <a:prstDash val="solid"/>
+                      <a:round/>
+                      <a:headEnd type="none" w="med" len="med"/>
+                      <a:tailEnd type="none" w="med" len="med"/>
+                    </a:lnL>
+                    <a:lnR w="6350" cap="flat" cmpd="sng" algn="ctr">
+                      <a:solidFill>
+                        <a:srgbClr val="E9EEF5"/>
+                      </a:solidFill>
+                      <a:prstDash val="solid"/>
+                      <a:round/>
+                      <a:headEnd type="none" w="med" len="med"/>
+                      <a:tailEnd type="none" w="med" len="med"/>
+                    </a:lnR>
+                    <a:lnT w="6350" cap="flat" cmpd="sng" algn="ctr">
+                      <a:solidFill>
+                        <a:srgbClr val="E9EEF5"/>
+                      </a:solidFill>
+                      <a:prstDash val="solid"/>
+                      <a:round/>
+                      <a:headEnd type="none" w="med" len="med"/>
+                      <a:tailEnd type="none" w="med" len="med"/>
+                    </a:lnT>
+                    <a:lnB w="6350" cap="flat" cmpd="sng" algn="ctr">
+                      <a:solidFill>
+                        <a:srgbClr val="E9EEF5"/>
+                      </a:solidFill>
+                      <a:prstDash val="solid"/>
+                      <a:round/>
+                      <a:headEnd type="none" w="med" len="med"/>
+                      <a:tailEnd type="none" w="med" len="med"/>
+                    </a:lnB>
+                    <a:solidFill>
+                      <a:srgbClr val="F1F5FB"/>
+                    </a:solidFill>
+                  </a:tcPr>
+                </a:tc>
+                <a:tc>
+                  <a:txBody>
+                    <a:bodyPr/>
+                    <a:lstStyle/>
+                    <a:p>
+                      <a:pPr algn="ctr" indent="0" marL="0">
+                        <a:buNone/>
+                      </a:pPr>
+                      <a:r>
+                        <a:rPr lang="en-US" sz="1050" b="1" dirty="0">
+                          <a:solidFill>
+                            <a:srgbClr val="475569"/>
+                          </a:solidFill>
+                          <a:latin typeface="Calibri" pitchFamily="34" charset="0"/>
+                          <a:ea typeface="Calibri" pitchFamily="34" charset="-122"/>
+                          <a:cs typeface="Calibri" pitchFamily="34" charset="-120"/>
+                        </a:rPr>
+                        <a:t>Issues</a:t>
+                      </a:r>
+                      <a:endParaRPr lang="en-US" sz="1050" dirty="0">
+                        <a:latin typeface="Calibri" charset="0"/>
+                        <a:ea typeface="Calibri" charset="0"/>
+                        <a:cs typeface="Calibri" charset="0"/>
+                      </a:endParaRPr>
+                    </a:p>
+                  </a:txBody>
+                  <a:tcPr marL="91440" marR="91440" marT="45720" marB="45720" anchor="ctr">
+                    <a:lnL w="6350" cap="flat" cmpd="sng" algn="ctr">
+                      <a:solidFill>
+                        <a:srgbClr val="E9EEF5"/>
+                      </a:solidFill>
+                      <a:prstDash val="solid"/>
+                      <a:round/>
+                      <a:headEnd type="none" w="med" len="med"/>
+                      <a:tailEnd type="none" w="med" len="med"/>
+                    </a:lnL>
+                    <a:lnR w="6350" cap="flat" cmpd="sng" algn="ctr">
+                      <a:solidFill>
+                        <a:srgbClr val="E9EEF5"/>
+                      </a:solidFill>
+                      <a:prstDash val="solid"/>
+                      <a:round/>
+                      <a:headEnd type="none" w="med" len="med"/>
+                      <a:tailEnd type="none" w="med" len="med"/>
+                    </a:lnR>
+                    <a:lnT w="6350" cap="flat" cmpd="sng" algn="ctr">
+                      <a:solidFill>
+                        <a:srgbClr val="E9EEF5"/>
+                      </a:solidFill>
+                      <a:prstDash val="solid"/>
+                      <a:round/>
+                      <a:headEnd type="none" w="med" len="med"/>
+                      <a:tailEnd type="none" w="med" len="med"/>
+                    </a:lnT>
+                    <a:lnB w="6350" cap="flat" cmpd="sng" algn="ctr">
+                      <a:solidFill>
+                        <a:srgbClr val="E9EEF5"/>
+                      </a:solidFill>
+                      <a:prstDash val="solid"/>
+                      <a:round/>
+                      <a:headEnd type="none" w="med" len="med"/>
+                      <a:tailEnd type="none" w="med" len="med"/>
+                    </a:lnB>
+                    <a:solidFill>
+                      <a:srgbClr val="F1F5FB"/>
+                    </a:solidFill>
+                  </a:tcPr>
+                </a:tc>
+                <a:tc>
+                  <a:txBody>
+                    <a:bodyPr/>
+                    <a:lstStyle/>
+                    <a:p>
+                      <a:pPr algn="ctr" indent="0" marL="0">
+                        <a:buNone/>
+                      </a:pPr>
+                      <a:r>
+                        <a:rPr lang="en-US" sz="1050" b="1" dirty="0">
+                          <a:solidFill>
+                            <a:srgbClr val="475569"/>
+                          </a:solidFill>
+                          <a:latin typeface="Calibri" pitchFamily="34" charset="0"/>
+                          <a:ea typeface="Calibri" pitchFamily="34" charset="-122"/>
+                          <a:cs typeface="Calibri" pitchFamily="34" charset="-120"/>
+                        </a:rPr>
+                        <a:t>Status</a:t>
+                      </a:r>
+                      <a:endParaRPr lang="en-US" sz="1050" dirty="0">
+                        <a:latin typeface="Calibri" charset="0"/>
+                        <a:ea typeface="Calibri" charset="0"/>
+                        <a:cs typeface="Calibri" charset="0"/>
+                      </a:endParaRPr>
+                    </a:p>
+                  </a:txBody>
+                  <a:tcPr marL="91440" marR="91440" marT="45720" marB="45720" anchor="ctr">
+                    <a:lnL w="6350" cap="flat" cmpd="sng" algn="ctr">
+                      <a:solidFill>
+                        <a:srgbClr val="E9EEF5"/>
+                      </a:solidFill>
+                      <a:prstDash val="solid"/>
+                      <a:round/>
+                      <a:headEnd type="none" w="med" len="med"/>
+                      <a:tailEnd type="none" w="med" len="med"/>
+                    </a:lnL>
+                    <a:lnR w="6350" cap="flat" cmpd="sng" algn="ctr">
+                      <a:solidFill>
+                        <a:srgbClr val="E9EEF5"/>
+                      </a:solidFill>
+                      <a:prstDash val="solid"/>
+                      <a:round/>
+                      <a:headEnd type="none" w="med" len="med"/>
+                      <a:tailEnd type="none" w="med" len="med"/>
+                    </a:lnR>
+                    <a:lnT w="6350" cap="flat" cmpd="sng" algn="ctr">
+                      <a:solidFill>
+                        <a:srgbClr val="E9EEF5"/>
+                      </a:solidFill>
+                      <a:prstDash val="solid"/>
+                      <a:round/>
+                      <a:headEnd type="none" w="med" len="med"/>
+                      <a:tailEnd type="none" w="med" len="med"/>
+                    </a:lnT>
+                    <a:lnB w="6350" cap="flat" cmpd="sng" algn="ctr">
+                      <a:solidFill>
+                        <a:srgbClr val="E9EEF5"/>
+                      </a:solidFill>
+                      <a:prstDash val="solid"/>
+                      <a:round/>
+                      <a:headEnd type="none" w="med" len="med"/>
+                      <a:tailEnd type="none" w="med" len="med"/>
+                    </a:lnB>
+                    <a:solidFill>
+                      <a:srgbClr val="F1F5FB"/>
+                    </a:solidFill>
+                  </a:tcPr>
+                </a:tc>
+              </a:tr>
+              <a:tr h="329184">
+                <a:tc>
+                  <a:txBody>
+                    <a:bodyPr/>
+                    <a:lstStyle/>
+                    <a:p>
+                      <a:pPr algn="l" indent="0" marL="0">
+                        <a:buNone/>
+                      </a:pPr>
+                      <a:r>
+                        <a:rPr lang="en-US" sz="1100" dirty="0">
+                          <a:solidFill>
+                            <a:srgbClr val="17233B"/>
+                          </a:solidFill>
+                          <a:latin typeface="Calibri" pitchFamily="34" charset="0"/>
+                          <a:ea typeface="Calibri" pitchFamily="34" charset="-122"/>
+                          <a:cs typeface="Calibri" pitchFamily="34" charset="-120"/>
+                        </a:rPr>
+                        <a:t>wpl-wealth</a:t>
+                      </a:r>
+                      <a:endParaRPr lang="en-US" sz="1100" dirty="0">
+                        <a:latin typeface="Calibri" charset="0"/>
+                        <a:ea typeface="Calibri" charset="0"/>
+                        <a:cs typeface="Calibri" charset="0"/>
+                      </a:endParaRPr>
+                    </a:p>
+                  </a:txBody>
+                  <a:tcPr marL="91440" marR="91440" marT="45720" marB="45720" anchor="ctr">
+                    <a:lnL w="6350" cap="flat" cmpd="sng" algn="ctr">
+                      <a:solidFill>
+                        <a:srgbClr val="E9EEF5"/>
+                      </a:solidFill>
+                      <a:prstDash val="solid"/>
+                      <a:round/>
+                      <a:headEnd type="none" w="med" len="med"/>
+                      <a:tailEnd type="none" w="med" len="med"/>
+                    </a:lnL>
+                    <a:lnR w="6350" cap="flat" cmpd="sng" algn="ctr">
+                      <a:solidFill>
+                        <a:srgbClr val="E9EEF5"/>
+                      </a:solidFill>
+                      <a:prstDash val="solid"/>
+                      <a:round/>
+                      <a:headEnd type="none" w="med" len="med"/>
+                      <a:tailEnd type="none" w="med" len="med"/>
+                    </a:lnR>
+                    <a:lnT w="6350" cap="flat" cmpd="sng" algn="ctr">
+                      <a:solidFill>
+                        <a:srgbClr val="E9EEF5"/>
+                      </a:solidFill>
+                      <a:prstDash val="solid"/>
+                      <a:round/>
+                      <a:headEnd type="none" w="med" len="med"/>
+                      <a:tailEnd type="none" w="med" len="med"/>
+                    </a:lnT>
+                    <a:lnB w="6350" cap="flat" cmpd="sng" algn="ctr">
+                      <a:solidFill>
+                        <a:srgbClr val="E9EEF5"/>
+                      </a:solidFill>
+                      <a:prstDash val="solid"/>
+                      <a:round/>
+                      <a:headEnd type="none" w="med" len="med"/>
+                      <a:tailEnd type="none" w="med" len="med"/>
+                    </a:lnB>
+                  </a:tcPr>
+                </a:tc>
+                <a:tc>
+                  <a:txBody>
+                    <a:bodyPr/>
+                    <a:lstStyle/>
+                    <a:p>
+                      <a:pPr algn="ctr" indent="0" marL="0">
+                        <a:buNone/>
+                      </a:pPr>
+                      <a:r>
+                        <a:rPr lang="en-US" sz="1100" dirty="0">
+                          <a:solidFill>
+                            <a:srgbClr val="17233B"/>
+                          </a:solidFill>
+                          <a:latin typeface="Calibri" pitchFamily="34" charset="0"/>
+                          <a:ea typeface="Calibri" pitchFamily="34" charset="-122"/>
+                          <a:cs typeface="Calibri" pitchFamily="34" charset="-120"/>
+                        </a:rPr>
+                        <a:t>18</a:t>
+                      </a:r>
+                      <a:endParaRPr lang="en-US" sz="1100" dirty="0">
+                        <a:latin typeface="Calibri" charset="0"/>
+                        <a:ea typeface="Calibri" charset="0"/>
+                        <a:cs typeface="Calibri" charset="0"/>
+                      </a:endParaRPr>
+                    </a:p>
+                  </a:txBody>
+                  <a:tcPr marL="91440" marR="91440" marT="45720" marB="45720" anchor="ctr">
+                    <a:lnL w="6350" cap="flat" cmpd="sng" algn="ctr">
+                      <a:solidFill>
+                        <a:srgbClr val="E9EEF5"/>
+                      </a:solidFill>
+                      <a:prstDash val="solid"/>
+                      <a:round/>
+                      <a:headEnd type="none" w="med" len="med"/>
+                      <a:tailEnd type="none" w="med" len="med"/>
+                    </a:lnL>
+                    <a:lnR w="6350" cap="flat" cmpd="sng" algn="ctr">
+                      <a:solidFill>
+                        <a:srgbClr val="E9EEF5"/>
+                      </a:solidFill>
+                      <a:prstDash val="solid"/>
+                      <a:round/>
+                      <a:headEnd type="none" w="med" len="med"/>
+                      <a:tailEnd type="none" w="med" len="med"/>
+                    </a:lnR>
+                    <a:lnT w="6350" cap="flat" cmpd="sng" algn="ctr">
+                      <a:solidFill>
+                        <a:srgbClr val="E9EEF5"/>
+                      </a:solidFill>
+                      <a:prstDash val="solid"/>
+                      <a:round/>
+                      <a:headEnd type="none" w="med" len="med"/>
+                      <a:tailEnd type="none" w="med" len="med"/>
+                    </a:lnT>
+                    <a:lnB w="6350" cap="flat" cmpd="sng" algn="ctr">
+                      <a:solidFill>
+                        <a:srgbClr val="E9EEF5"/>
+                      </a:solidFill>
+                      <a:prstDash val="solid"/>
+                      <a:round/>
+                      <a:headEnd type="none" w="med" len="med"/>
+                      <a:tailEnd type="none" w="med" len="med"/>
+                    </a:lnB>
+                  </a:tcPr>
+                </a:tc>
+                <a:tc>
+                  <a:txBody>
+                    <a:bodyPr/>
+                    <a:lstStyle/>
+                    <a:p>
+                      <a:pPr algn="ctr" indent="0" marL="0">
+                        <a:buNone/>
+                      </a:pPr>
+                      <a:r>
+                        <a:rPr lang="en-US" sz="1100" dirty="0">
+                          <a:solidFill>
+                            <a:srgbClr val="17233B"/>
+                          </a:solidFill>
+                          <a:latin typeface="Calibri" pitchFamily="34" charset="0"/>
+                          <a:ea typeface="Calibri" pitchFamily="34" charset="-122"/>
+                          <a:cs typeface="Calibri" pitchFamily="34" charset="-120"/>
+                        </a:rPr>
+                        <a:t>5</a:t>
+                      </a:r>
+                      <a:endParaRPr lang="en-US" sz="1100" dirty="0">
+                        <a:latin typeface="Calibri" charset="0"/>
+                        <a:ea typeface="Calibri" charset="0"/>
+                        <a:cs typeface="Calibri" charset="0"/>
+                      </a:endParaRPr>
+                    </a:p>
+                  </a:txBody>
+                  <a:tcPr marL="91440" marR="91440" marT="45720" marB="45720" anchor="ctr">
+                    <a:lnL w="6350" cap="flat" cmpd="sng" algn="ctr">
+                      <a:solidFill>
+                        <a:srgbClr val="E9EEF5"/>
+                      </a:solidFill>
+                      <a:prstDash val="solid"/>
+                      <a:round/>
+                      <a:headEnd type="none" w="med" len="med"/>
+                      <a:tailEnd type="none" w="med" len="med"/>
+                    </a:lnL>
+                    <a:lnR w="6350" cap="flat" cmpd="sng" algn="ctr">
+                      <a:solidFill>
+                        <a:srgbClr val="E9EEF5"/>
+                      </a:solidFill>
+                      <a:prstDash val="solid"/>
+                      <a:round/>
+                      <a:headEnd type="none" w="med" len="med"/>
+                      <a:tailEnd type="none" w="med" len="med"/>
+                    </a:lnR>
+                    <a:lnT w="6350" cap="flat" cmpd="sng" algn="ctr">
+                      <a:solidFill>
+                        <a:srgbClr val="E9EEF5"/>
+                      </a:solidFill>
+                      <a:prstDash val="solid"/>
+                      <a:round/>
+                      <a:headEnd type="none" w="med" len="med"/>
+                      <a:tailEnd type="none" w="med" len="med"/>
+                    </a:lnT>
+                    <a:lnB w="6350" cap="flat" cmpd="sng" algn="ctr">
+                      <a:solidFill>
+                        <a:srgbClr val="E9EEF5"/>
+                      </a:solidFill>
+                      <a:prstDash val="solid"/>
+                      <a:round/>
+                      <a:headEnd type="none" w="med" len="med"/>
+                      <a:tailEnd type="none" w="med" len="med"/>
+                    </a:lnB>
+                  </a:tcPr>
+                </a:tc>
+                <a:tc>
+                  <a:txBody>
+                    <a:bodyPr/>
+                    <a:lstStyle/>
+                    <a:p>
+                      <a:pPr algn="ctr" indent="0" marL="0">
+                        <a:buNone/>
+                      </a:pPr>
+                      <a:r>
+                        <a:rPr lang="en-US" sz="1100" dirty="0">
+                          <a:solidFill>
+                            <a:srgbClr val="17233B"/>
+                          </a:solidFill>
+                          <a:latin typeface="Calibri" pitchFamily="34" charset="0"/>
+                          <a:ea typeface="Calibri" pitchFamily="34" charset="-122"/>
+                          <a:cs typeface="Calibri" pitchFamily="34" charset="-120"/>
+                        </a:rPr>
+                        <a:t>13</a:t>
+                      </a:r>
+                      <a:endParaRPr lang="en-US" sz="1100" dirty="0">
+                        <a:latin typeface="Calibri" charset="0"/>
+                        <a:ea typeface="Calibri" charset="0"/>
+                        <a:cs typeface="Calibri" charset="0"/>
+                      </a:endParaRPr>
+                    </a:p>
+                  </a:txBody>
+                  <a:tcPr marL="91440" marR="91440" marT="45720" marB="45720" anchor="ctr">
+                    <a:lnL w="6350" cap="flat" cmpd="sng" algn="ctr">
+                      <a:solidFill>
+                        <a:srgbClr val="E9EEF5"/>
+                      </a:solidFill>
+                      <a:prstDash val="solid"/>
+                      <a:round/>
+                      <a:headEnd type="none" w="med" len="med"/>
+                      <a:tailEnd type="none" w="med" len="med"/>
+                    </a:lnL>
+                    <a:lnR w="6350" cap="flat" cmpd="sng" algn="ctr">
+                      <a:solidFill>
+                        <a:srgbClr val="E9EEF5"/>
+                      </a:solidFill>
+                      <a:prstDash val="solid"/>
+                      <a:round/>
+                      <a:headEnd type="none" w="med" len="med"/>
+                      <a:tailEnd type="none" w="med" len="med"/>
+                    </a:lnR>
+                    <a:lnT w="6350" cap="flat" cmpd="sng" algn="ctr">
+                      <a:solidFill>
+                        <a:srgbClr val="E9EEF5"/>
+                      </a:solidFill>
+                      <a:prstDash val="solid"/>
+                      <a:round/>
+                      <a:headEnd type="none" w="med" len="med"/>
+                      <a:tailEnd type="none" w="med" len="med"/>
+                    </a:lnT>
+                    <a:lnB w="6350" cap="flat" cmpd="sng" algn="ctr">
+                      <a:solidFill>
+                        <a:srgbClr val="E9EEF5"/>
+                      </a:solidFill>
+                      <a:prstDash val="solid"/>
+                      <a:round/>
+                      <a:headEnd type="none" w="med" len="med"/>
+                      <a:tailEnd type="none" w="med" len="med"/>
+                    </a:lnB>
+                  </a:tcPr>
+                </a:tc>
+                <a:tc>
+                  <a:txBody>
+                    <a:bodyPr/>
+                    <a:lstStyle/>
+                    <a:p>
+                      <a:pPr algn="ctr" indent="0" marL="0">
+                        <a:buNone/>
+                      </a:pPr>
+                      <a:r>
+                        <a:rPr lang="en-US" sz="1100" dirty="0">
+                          <a:solidFill>
+                            <a:srgbClr val="17233B"/>
+                          </a:solidFill>
+                          <a:latin typeface="Calibri" pitchFamily="34" charset="0"/>
+                          <a:ea typeface="Calibri" pitchFamily="34" charset="-122"/>
+                          <a:cs typeface="Calibri" pitchFamily="34" charset="-120"/>
+                        </a:rPr>
+                        <a:t>2</a:t>
+                      </a:r>
+                      <a:endParaRPr lang="en-US" sz="1100" dirty="0">
+                        <a:latin typeface="Calibri" charset="0"/>
+                        <a:ea typeface="Calibri" charset="0"/>
+                        <a:cs typeface="Calibri" charset="0"/>
+                      </a:endParaRPr>
+                    </a:p>
+                  </a:txBody>
+                  <a:tcPr marL="91440" marR="91440" marT="45720" marB="45720" anchor="ctr">
+                    <a:lnL w="6350" cap="flat" cmpd="sng" algn="ctr">
+                      <a:solidFill>
+                        <a:srgbClr val="E9EEF5"/>
+                      </a:solidFill>
+                      <a:prstDash val="solid"/>
+                      <a:round/>
+                      <a:headEnd type="none" w="med" len="med"/>
+                      <a:tailEnd type="none" w="med" len="med"/>
+                    </a:lnL>
+                    <a:lnR w="6350" cap="flat" cmpd="sng" algn="ctr">
+                      <a:solidFill>
+                        <a:srgbClr val="E9EEF5"/>
+                      </a:solidFill>
+                      <a:prstDash val="solid"/>
+                      <a:round/>
+                      <a:headEnd type="none" w="med" len="med"/>
+                      <a:tailEnd type="none" w="med" len="med"/>
+                    </a:lnR>
+                    <a:lnT w="6350" cap="flat" cmpd="sng" algn="ctr">
+                      <a:solidFill>
+                        <a:srgbClr val="E9EEF5"/>
+                      </a:solidFill>
+                      <a:prstDash val="solid"/>
+                      <a:round/>
+                      <a:headEnd type="none" w="med" len="med"/>
+                      <a:tailEnd type="none" w="med" len="med"/>
+                    </a:lnT>
+                    <a:lnB w="6350" cap="flat" cmpd="sng" algn="ctr">
+                      <a:solidFill>
+                        <a:srgbClr val="E9EEF5"/>
+                      </a:solidFill>
+                      <a:prstDash val="solid"/>
+                      <a:round/>
+                      <a:headEnd type="none" w="med" len="med"/>
+                      <a:tailEnd type="none" w="med" len="med"/>
+                    </a:lnB>
+                  </a:tcPr>
+                </a:tc>
+                <a:tc>
+                  <a:txBody>
+                    <a:bodyPr/>
+                    <a:lstStyle/>
+                    <a:p>
+                      <a:pPr algn="ctr" indent="0" marL="0">
+                        <a:buNone/>
+                      </a:pPr>
+                      <a:r>
+                        <a:rPr lang="en-US" sz="1050" b="1" dirty="0">
+                          <a:solidFill>
+                            <a:srgbClr val="B91C1C"/>
+                          </a:solidFill>
+                          <a:latin typeface="Calibri" pitchFamily="34" charset="0"/>
+                          <a:ea typeface="Calibri" pitchFamily="34" charset="-122"/>
+                          <a:cs typeface="Calibri" pitchFamily="34" charset="-120"/>
+                        </a:rPr>
+                        <a:t>At risk</a:t>
+                      </a:r>
+                      <a:endParaRPr lang="en-US" sz="1050" dirty="0">
+                        <a:latin typeface="Calibri" charset="0"/>
+                        <a:ea typeface="Calibri" charset="0"/>
+                        <a:cs typeface="Calibri" charset="0"/>
+                      </a:endParaRPr>
+                    </a:p>
+                  </a:txBody>
+                  <a:tcPr marL="91440" marR="91440" marT="45720" marB="45720" anchor="ctr">
+                    <a:lnL w="6350" cap="flat" cmpd="sng" algn="ctr">
+                      <a:solidFill>
+                        <a:srgbClr val="E9EEF5"/>
+                      </a:solidFill>
+                      <a:prstDash val="solid"/>
+                      <a:round/>
+                      <a:headEnd type="none" w="med" len="med"/>
+                      <a:tailEnd type="none" w="med" len="med"/>
+                    </a:lnL>
+                    <a:lnR w="6350" cap="flat" cmpd="sng" algn="ctr">
+                      <a:solidFill>
+                        <a:srgbClr val="E9EEF5"/>
+                      </a:solidFill>
+                      <a:prstDash val="solid"/>
+                      <a:round/>
+                      <a:headEnd type="none" w="med" len="med"/>
+                      <a:tailEnd type="none" w="med" len="med"/>
+                    </a:lnR>
+                    <a:lnT w="6350" cap="flat" cmpd="sng" algn="ctr">
+                      <a:solidFill>
+                        <a:srgbClr val="E9EEF5"/>
+                      </a:solidFill>
+                      <a:prstDash val="solid"/>
+                      <a:round/>
+                      <a:headEnd type="none" w="med" len="med"/>
+                      <a:tailEnd type="none" w="med" len="med"/>
+                    </a:lnT>
+                    <a:lnB w="6350" cap="flat" cmpd="sng" algn="ctr">
+                      <a:solidFill>
+                        <a:srgbClr val="E9EEF5"/>
+                      </a:solidFill>
+                      <a:prstDash val="solid"/>
+                      <a:round/>
+                      <a:headEnd type="none" w="med" len="med"/>
+                      <a:tailEnd type="none" w="med" len="med"/>
+                    </a:lnB>
+                    <a:solidFill>
+                      <a:srgbClr val="FEE2E2"/>
+                    </a:solidFill>
+                  </a:tcPr>
+                </a:tc>
+              </a:tr>
+              <a:tr h="329184">
+                <a:tc>
+                  <a:txBody>
+                    <a:bodyPr/>
+                    <a:lstStyle/>
+                    <a:p>
+                      <a:pPr algn="l" indent="0" marL="0">
+                        <a:buNone/>
+                      </a:pPr>
+                      <a:r>
+                        <a:rPr lang="en-US" sz="1100" dirty="0">
+                          <a:solidFill>
+                            <a:srgbClr val="17233B"/>
+                          </a:solidFill>
+                          <a:latin typeface="Calibri" pitchFamily="34" charset="0"/>
+                          <a:ea typeface="Calibri" pitchFamily="34" charset="-122"/>
+                          <a:cs typeface="Calibri" pitchFamily="34" charset="-120"/>
+                        </a:rPr>
+                        <a:t>mighty</a:t>
+                      </a:r>
+                      <a:endParaRPr lang="en-US" sz="1100" dirty="0">
+                        <a:latin typeface="Calibri" charset="0"/>
+                        <a:ea typeface="Calibri" charset="0"/>
+                        <a:cs typeface="Calibri" charset="0"/>
+                      </a:endParaRPr>
+                    </a:p>
+                  </a:txBody>
+                  <a:tcPr marL="91440" marR="91440" marT="45720" marB="45720" anchor="ctr">
+                    <a:lnL w="6350" cap="flat" cmpd="sng" algn="ctr">
+                      <a:solidFill>
+                        <a:srgbClr val="E9EEF5"/>
+                      </a:solidFill>
+                      <a:prstDash val="solid"/>
+                      <a:round/>
+                      <a:headEnd type="none" w="med" len="med"/>
+                      <a:tailEnd type="none" w="med" len="med"/>
+                    </a:lnL>
+                    <a:lnR w="6350" cap="flat" cmpd="sng" algn="ctr">
+                      <a:solidFill>
+                        <a:srgbClr val="E9EEF5"/>
+                      </a:solidFill>
+                      <a:prstDash val="solid"/>
+                      <a:round/>
+                      <a:headEnd type="none" w="med" len="med"/>
+                      <a:tailEnd type="none" w="med" len="med"/>
+                    </a:lnR>
+                    <a:lnT w="6350" cap="flat" cmpd="sng" algn="ctr">
+                      <a:solidFill>
+                        <a:srgbClr val="E9EEF5"/>
+                      </a:solidFill>
+                      <a:prstDash val="solid"/>
+                      <a:round/>
+                      <a:headEnd type="none" w="med" len="med"/>
+                      <a:tailEnd type="none" w="med" len="med"/>
+                    </a:lnT>
+                    <a:lnB w="6350" cap="flat" cmpd="sng" algn="ctr">
+                      <a:solidFill>
+                        <a:srgbClr val="E9EEF5"/>
+                      </a:solidFill>
+                      <a:prstDash val="solid"/>
+                      <a:round/>
+                      <a:headEnd type="none" w="med" len="med"/>
+                      <a:tailEnd type="none" w="med" len="med"/>
+                    </a:lnB>
+                  </a:tcPr>
+                </a:tc>
+                <a:tc>
+                  <a:txBody>
+                    <a:bodyPr/>
+                    <a:lstStyle/>
+                    <a:p>
+                      <a:pPr algn="ctr" indent="0" marL="0">
+                        <a:buNone/>
+                      </a:pPr>
+                      <a:r>
+                        <a:rPr lang="en-US" sz="1100" dirty="0">
+                          <a:solidFill>
+                            <a:srgbClr val="17233B"/>
+                          </a:solidFill>
+                          <a:latin typeface="Calibri" pitchFamily="34" charset="0"/>
+                          <a:ea typeface="Calibri" pitchFamily="34" charset="-122"/>
+                          <a:cs typeface="Calibri" pitchFamily="34" charset="-120"/>
+                        </a:rPr>
+                        <a:t>12</a:t>
+                      </a:r>
+                      <a:endParaRPr lang="en-US" sz="1100" dirty="0">
+                        <a:latin typeface="Calibri" charset="0"/>
+                        <a:ea typeface="Calibri" charset="0"/>
+                        <a:cs typeface="Calibri" charset="0"/>
+                      </a:endParaRPr>
+                    </a:p>
+                  </a:txBody>
+                  <a:tcPr marL="91440" marR="91440" marT="45720" marB="45720" anchor="ctr">
+                    <a:lnL w="6350" cap="flat" cmpd="sng" algn="ctr">
+                      <a:solidFill>
+                        <a:srgbClr val="E9EEF5"/>
+                      </a:solidFill>
+                      <a:prstDash val="solid"/>
+                      <a:round/>
+                      <a:headEnd type="none" w="med" len="med"/>
+                      <a:tailEnd type="none" w="med" len="med"/>
+                    </a:lnL>
+                    <a:lnR w="6350" cap="flat" cmpd="sng" algn="ctr">
+                      <a:solidFill>
+                        <a:srgbClr val="E9EEF5"/>
+                      </a:solidFill>
+                      <a:prstDash val="solid"/>
+                      <a:round/>
+                      <a:headEnd type="none" w="med" len="med"/>
+                      <a:tailEnd type="none" w="med" len="med"/>
+                    </a:lnR>
+                    <a:lnT w="6350" cap="flat" cmpd="sng" algn="ctr">
+                      <a:solidFill>
+                        <a:srgbClr val="E9EEF5"/>
+                      </a:solidFill>
+                      <a:prstDash val="solid"/>
+                      <a:round/>
+                      <a:headEnd type="none" w="med" len="med"/>
+                      <a:tailEnd type="none" w="med" len="med"/>
+                    </a:lnT>
+                    <a:lnB w="6350" cap="flat" cmpd="sng" algn="ctr">
+                      <a:solidFill>
+                        <a:srgbClr val="E9EEF5"/>
+                      </a:solidFill>
+                      <a:prstDash val="solid"/>
+                      <a:round/>
+                      <a:headEnd type="none" w="med" len="med"/>
+                      <a:tailEnd type="none" w="med" len="med"/>
+                    </a:lnB>
+                  </a:tcPr>
+                </a:tc>
+                <a:tc>
+                  <a:txBody>
+                    <a:bodyPr/>
+                    <a:lstStyle/>
+                    <a:p>
+                      <a:pPr algn="ctr" indent="0" marL="0">
+                        <a:buNone/>
+                      </a:pPr>
+                      <a:r>
+                        <a:rPr lang="en-US" sz="1100" dirty="0">
+                          <a:solidFill>
+                            <a:srgbClr val="17233B"/>
+                          </a:solidFill>
+                          <a:latin typeface="Calibri" pitchFamily="34" charset="0"/>
+                          <a:ea typeface="Calibri" pitchFamily="34" charset="-122"/>
+                          <a:cs typeface="Calibri" pitchFamily="34" charset="-120"/>
+                        </a:rPr>
+                        <a:t>11</a:t>
+                      </a:r>
+                      <a:endParaRPr lang="en-US" sz="1100" dirty="0">
+                        <a:latin typeface="Calibri" charset="0"/>
+                        <a:ea typeface="Calibri" charset="0"/>
+                        <a:cs typeface="Calibri" charset="0"/>
+                      </a:endParaRPr>
+                    </a:p>
+                  </a:txBody>
+                  <a:tcPr marL="91440" marR="91440" marT="45720" marB="45720" anchor="ctr">
+                    <a:lnL w="6350" cap="flat" cmpd="sng" algn="ctr">
+                      <a:solidFill>
+                        <a:srgbClr val="E9EEF5"/>
+                      </a:solidFill>
+                      <a:prstDash val="solid"/>
+                      <a:round/>
+                      <a:headEnd type="none" w="med" len="med"/>
+                      <a:tailEnd type="none" w="med" len="med"/>
+                    </a:lnL>
+                    <a:lnR w="6350" cap="flat" cmpd="sng" algn="ctr">
+                      <a:solidFill>
+                        <a:srgbClr val="E9EEF5"/>
+                      </a:solidFill>
+                      <a:prstDash val="solid"/>
+                      <a:round/>
+                      <a:headEnd type="none" w="med" len="med"/>
+                      <a:tailEnd type="none" w="med" len="med"/>
+                    </a:lnR>
+                    <a:lnT w="6350" cap="flat" cmpd="sng" algn="ctr">
+                      <a:solidFill>
+                        <a:srgbClr val="E9EEF5"/>
+                      </a:solidFill>
+                      <a:prstDash val="solid"/>
+                      <a:round/>
+                      <a:headEnd type="none" w="med" len="med"/>
+                      <a:tailEnd type="none" w="med" len="med"/>
+                    </a:lnT>
+                    <a:lnB w="6350" cap="flat" cmpd="sng" algn="ctr">
+                      <a:solidFill>
+                        <a:srgbClr val="E9EEF5"/>
+                      </a:solidFill>
+                      <a:prstDash val="solid"/>
+                      <a:round/>
+                      <a:headEnd type="none" w="med" len="med"/>
+                      <a:tailEnd type="none" w="med" len="med"/>
+                    </a:lnB>
+                  </a:tcPr>
+                </a:tc>
+                <a:tc>
+                  <a:txBody>
+                    <a:bodyPr/>
+                    <a:lstStyle/>
+                    <a:p>
+                      <a:pPr algn="ctr" indent="0" marL="0">
+                        <a:buNone/>
+                      </a:pPr>
+                      <a:r>
+                        <a:rPr lang="en-US" sz="1100" dirty="0">
+                          <a:solidFill>
+                            <a:srgbClr val="17233B"/>
+                          </a:solidFill>
+                          <a:latin typeface="Calibri" pitchFamily="34" charset="0"/>
+                          <a:ea typeface="Calibri" pitchFamily="34" charset="-122"/>
+                          <a:cs typeface="Calibri" pitchFamily="34" charset="-120"/>
+                        </a:rPr>
+                        <a:t>1</a:t>
+                      </a:r>
+                      <a:endParaRPr lang="en-US" sz="1100" dirty="0">
+                        <a:latin typeface="Calibri" charset="0"/>
+                        <a:ea typeface="Calibri" charset="0"/>
+                        <a:cs typeface="Calibri" charset="0"/>
+                      </a:endParaRPr>
+                    </a:p>
+                  </a:txBody>
+                  <a:tcPr marL="91440" marR="91440" marT="45720" marB="45720" anchor="ctr">
+                    <a:lnL w="6350" cap="flat" cmpd="sng" algn="ctr">
+                      <a:solidFill>
+                        <a:srgbClr val="E9EEF5"/>
+                      </a:solidFill>
+                      <a:prstDash val="solid"/>
+                      <a:round/>
+                      <a:headEnd type="none" w="med" len="med"/>
+                      <a:tailEnd type="none" w="med" len="med"/>
+                    </a:lnL>
+                    <a:lnR w="6350" cap="flat" cmpd="sng" algn="ctr">
+                      <a:solidFill>
+                        <a:srgbClr val="E9EEF5"/>
+                      </a:solidFill>
+                      <a:prstDash val="solid"/>
+                      <a:round/>
+                      <a:headEnd type="none" w="med" len="med"/>
+                      <a:tailEnd type="none" w="med" len="med"/>
+                    </a:lnR>
+                    <a:lnT w="6350" cap="flat" cmpd="sng" algn="ctr">
+                      <a:solidFill>
+                        <a:srgbClr val="E9EEF5"/>
+                      </a:solidFill>
+                      <a:prstDash val="solid"/>
+                      <a:round/>
+                      <a:headEnd type="none" w="med" len="med"/>
+                      <a:tailEnd type="none" w="med" len="med"/>
+                    </a:lnT>
+                    <a:lnB w="6350" cap="flat" cmpd="sng" algn="ctr">
+                      <a:solidFill>
+                        <a:srgbClr val="E9EEF5"/>
+                      </a:solidFill>
+                      <a:prstDash val="solid"/>
+                      <a:round/>
+                      <a:headEnd type="none" w="med" len="med"/>
+                      <a:tailEnd type="none" w="med" len="med"/>
+                    </a:lnB>
+                  </a:tcPr>
+                </a:tc>
+                <a:tc>
+                  <a:txBody>
+                    <a:bodyPr/>
+                    <a:lstStyle/>
+                    <a:p>
+                      <a:pPr algn="ctr" indent="0" marL="0">
+                        <a:buNone/>
+                      </a:pPr>
+                      <a:r>
+                        <a:rPr lang="en-US" sz="1100" dirty="0">
+                          <a:solidFill>
+                            <a:srgbClr val="17233B"/>
+                          </a:solidFill>
+                          <a:latin typeface="Calibri" pitchFamily="34" charset="0"/>
+                          <a:ea typeface="Calibri" pitchFamily="34" charset="-122"/>
+                          <a:cs typeface="Calibri" pitchFamily="34" charset="-120"/>
+                        </a:rPr>
+                        <a:t>—</a:t>
+                      </a:r>
+                      <a:endParaRPr lang="en-US" sz="1100" dirty="0">
+                        <a:latin typeface="Calibri" charset="0"/>
+                        <a:ea typeface="Calibri" charset="0"/>
+                        <a:cs typeface="Calibri" charset="0"/>
+                      </a:endParaRPr>
+                    </a:p>
+                  </a:txBody>
+                  <a:tcPr marL="91440" marR="91440" marT="45720" marB="45720" anchor="ctr">
+                    <a:lnL w="6350" cap="flat" cmpd="sng" algn="ctr">
+                      <a:solidFill>
+                        <a:srgbClr val="E9EEF5"/>
+                      </a:solidFill>
+                      <a:prstDash val="solid"/>
+                      <a:round/>
+                      <a:headEnd type="none" w="med" len="med"/>
+                      <a:tailEnd type="none" w="med" len="med"/>
+                    </a:lnL>
+                    <a:lnR w="6350" cap="flat" cmpd="sng" algn="ctr">
+                      <a:solidFill>
+                        <a:srgbClr val="E9EEF5"/>
+                      </a:solidFill>
+                      <a:prstDash val="solid"/>
+                      <a:round/>
+                      <a:headEnd type="none" w="med" len="med"/>
+                      <a:tailEnd type="none" w="med" len="med"/>
+                    </a:lnR>
+                    <a:lnT w="6350" cap="flat" cmpd="sng" algn="ctr">
+                      <a:solidFill>
+                        <a:srgbClr val="E9EEF5"/>
+                      </a:solidFill>
+                      <a:prstDash val="solid"/>
+                      <a:round/>
+                      <a:headEnd type="none" w="med" len="med"/>
+                      <a:tailEnd type="none" w="med" len="med"/>
+                    </a:lnT>
+                    <a:lnB w="6350" cap="flat" cmpd="sng" algn="ctr">
+                      <a:solidFill>
+                        <a:srgbClr val="E9EEF5"/>
+                      </a:solidFill>
+                      <a:prstDash val="solid"/>
+                      <a:round/>
+                      <a:headEnd type="none" w="med" len="med"/>
+                      <a:tailEnd type="none" w="med" len="med"/>
+                    </a:lnB>
+                  </a:tcPr>
+                </a:tc>
+                <a:tc>
+                  <a:txBody>
+                    <a:bodyPr/>
+                    <a:lstStyle/>
+                    <a:p>
+                      <a:pPr algn="ctr" indent="0" marL="0">
+                        <a:buNone/>
+                      </a:pPr>
+                      <a:r>
+                        <a:rPr lang="en-US" sz="1050" b="1" dirty="0">
+                          <a:solidFill>
+                            <a:srgbClr val="B45309"/>
+                          </a:solidFill>
+                          <a:latin typeface="Calibri" pitchFamily="34" charset="0"/>
+                          <a:ea typeface="Calibri" pitchFamily="34" charset="-122"/>
+                          <a:cs typeface="Calibri" pitchFamily="34" charset="-120"/>
+                        </a:rPr>
+                        <a:t>Review</a:t>
+                      </a:r>
+                      <a:endParaRPr lang="en-US" sz="1050" dirty="0">
+                        <a:latin typeface="Calibri" charset="0"/>
+                        <a:ea typeface="Calibri" charset="0"/>
+                        <a:cs typeface="Calibri" charset="0"/>
+                      </a:endParaRPr>
+                    </a:p>
+                  </a:txBody>
+                  <a:tcPr marL="91440" marR="91440" marT="45720" marB="45720" anchor="ctr">
+                    <a:lnL w="6350" cap="flat" cmpd="sng" algn="ctr">
+                      <a:solidFill>
+                        <a:srgbClr val="E9EEF5"/>
+                      </a:solidFill>
+                      <a:prstDash val="solid"/>
+                      <a:round/>
+                      <a:headEnd type="none" w="med" len="med"/>
+                      <a:tailEnd type="none" w="med" len="med"/>
+                    </a:lnL>
+                    <a:lnR w="6350" cap="flat" cmpd="sng" algn="ctr">
+                      <a:solidFill>
+                        <a:srgbClr val="E9EEF5"/>
+                      </a:solidFill>
+                      <a:prstDash val="solid"/>
+                      <a:round/>
+                      <a:headEnd type="none" w="med" len="med"/>
+                      <a:tailEnd type="none" w="med" len="med"/>
+                    </a:lnR>
+                    <a:lnT w="6350" cap="flat" cmpd="sng" algn="ctr">
+                      <a:solidFill>
+                        <a:srgbClr val="E9EEF5"/>
+                      </a:solidFill>
+                      <a:prstDash val="solid"/>
+                      <a:round/>
+                      <a:headEnd type="none" w="med" len="med"/>
+                      <a:tailEnd type="none" w="med" len="med"/>
+                    </a:lnT>
+                    <a:lnB w="6350" cap="flat" cmpd="sng" algn="ctr">
+                      <a:solidFill>
+                        <a:srgbClr val="E9EEF5"/>
+                      </a:solidFill>
+                      <a:prstDash val="solid"/>
+                      <a:round/>
+                      <a:headEnd type="none" w="med" len="med"/>
+                      <a:tailEnd type="none" w="med" len="med"/>
+                    </a:lnB>
+                    <a:solidFill>
+                      <a:srgbClr val="FEF3C7"/>
+                    </a:solidFill>
+                  </a:tcPr>
+                </a:tc>
+              </a:tr>
+              <a:tr h="329184">
+                <a:tc>
+                  <a:txBody>
+                    <a:bodyPr/>
+                    <a:lstStyle/>
+                    <a:p>
+                      <a:pPr algn="l" indent="0" marL="0">
+                        <a:buNone/>
+                      </a:pPr>
+                      <a:r>
+                        <a:rPr lang="en-US" sz="1100" dirty="0">
+                          <a:solidFill>
+                            <a:srgbClr val="17233B"/>
+                          </a:solidFill>
+                          <a:latin typeface="Calibri" pitchFamily="34" charset="0"/>
+                          <a:ea typeface="Calibri" pitchFamily="34" charset="-122"/>
+                          <a:cs typeface="Calibri" pitchFamily="34" charset="-120"/>
+                        </a:rPr>
+                        <a:t>spl-onboarding</a:t>
+                      </a:r>
+                      <a:endParaRPr lang="en-US" sz="1100" dirty="0">
+                        <a:latin typeface="Calibri" charset="0"/>
+                        <a:ea typeface="Calibri" charset="0"/>
+                        <a:cs typeface="Calibri" charset="0"/>
+                      </a:endParaRPr>
+                    </a:p>
+                  </a:txBody>
+                  <a:tcPr marL="91440" marR="91440" marT="45720" marB="45720" anchor="ctr">
+                    <a:lnL w="6350" cap="flat" cmpd="sng" algn="ctr">
+                      <a:solidFill>
+                        <a:srgbClr val="E9EEF5"/>
+                      </a:solidFill>
+                      <a:prstDash val="solid"/>
+                      <a:round/>
+                      <a:headEnd type="none" w="med" len="med"/>
+                      <a:tailEnd type="none" w="med" len="med"/>
+                    </a:lnL>
+                    <a:lnR w="6350" cap="flat" cmpd="sng" algn="ctr">
+                      <a:solidFill>
+                        <a:srgbClr val="E9EEF5"/>
+                      </a:solidFill>
+                      <a:prstDash val="solid"/>
+                      <a:round/>
+                      <a:headEnd type="none" w="med" len="med"/>
+                      <a:tailEnd type="none" w="med" len="med"/>
+                    </a:lnR>
+                    <a:lnT w="6350" cap="flat" cmpd="sng" algn="ctr">
+                      <a:solidFill>
+                        <a:srgbClr val="E9EEF5"/>
+                      </a:solidFill>
+                      <a:prstDash val="solid"/>
+                      <a:round/>
+                      <a:headEnd type="none" w="med" len="med"/>
+                      <a:tailEnd type="none" w="med" len="med"/>
+                    </a:lnT>
+                    <a:lnB w="6350" cap="flat" cmpd="sng" algn="ctr">
+                      <a:solidFill>
+                        <a:srgbClr val="E9EEF5"/>
+                      </a:solidFill>
+                      <a:prstDash val="solid"/>
+                      <a:round/>
+                      <a:headEnd type="none" w="med" len="med"/>
+                      <a:tailEnd type="none" w="med" len="med"/>
+                    </a:lnB>
+                  </a:tcPr>
+                </a:tc>
+                <a:tc>
+                  <a:txBody>
+                    <a:bodyPr/>
+                    <a:lstStyle/>
+                    <a:p>
+                      <a:pPr algn="ctr" indent="0" marL="0">
+                        <a:buNone/>
+                      </a:pPr>
+                      <a:r>
+                        <a:rPr lang="en-US" sz="1100" dirty="0">
+                          <a:solidFill>
+                            <a:srgbClr val="17233B"/>
+                          </a:solidFill>
+                          <a:latin typeface="Calibri" pitchFamily="34" charset="0"/>
+                          <a:ea typeface="Calibri" pitchFamily="34" charset="-122"/>
+                          <a:cs typeface="Calibri" pitchFamily="34" charset="-120"/>
+                        </a:rPr>
+                        <a:t>10</a:t>
+                      </a:r>
+                      <a:endParaRPr lang="en-US" sz="1100" dirty="0">
+                        <a:latin typeface="Calibri" charset="0"/>
+                        <a:ea typeface="Calibri" charset="0"/>
+                        <a:cs typeface="Calibri" charset="0"/>
+                      </a:endParaRPr>
+                    </a:p>
+                  </a:txBody>
+                  <a:tcPr marL="91440" marR="91440" marT="45720" marB="45720" anchor="ctr">
+                    <a:lnL w="6350" cap="flat" cmpd="sng" algn="ctr">
+                      <a:solidFill>
+                        <a:srgbClr val="E9EEF5"/>
+                      </a:solidFill>
+                      <a:prstDash val="solid"/>
+                      <a:round/>
+                      <a:headEnd type="none" w="med" len="med"/>
+                      <a:tailEnd type="none" w="med" len="med"/>
+                    </a:lnL>
+                    <a:lnR w="6350" cap="flat" cmpd="sng" algn="ctr">
+                      <a:solidFill>
+                        <a:srgbClr val="E9EEF5"/>
+                      </a:solidFill>
+                      <a:prstDash val="solid"/>
+                      <a:round/>
+                      <a:headEnd type="none" w="med" len="med"/>
+                      <a:tailEnd type="none" w="med" len="med"/>
+                    </a:lnR>
+                    <a:lnT w="6350" cap="flat" cmpd="sng" algn="ctr">
+                      <a:solidFill>
+                        <a:srgbClr val="E9EEF5"/>
+                      </a:solidFill>
+                      <a:prstDash val="solid"/>
+                      <a:round/>
+                      <a:headEnd type="none" w="med" len="med"/>
+                      <a:tailEnd type="none" w="med" len="med"/>
+                    </a:lnT>
+                    <a:lnB w="6350" cap="flat" cmpd="sng" algn="ctr">
+                      <a:solidFill>
+                        <a:srgbClr val="E9EEF5"/>
+                      </a:solidFill>
+                      <a:prstDash val="solid"/>
+                      <a:round/>
+                      <a:headEnd type="none" w="med" len="med"/>
+                      <a:tailEnd type="none" w="med" len="med"/>
+                    </a:lnB>
+                  </a:tcPr>
+                </a:tc>
+                <a:tc>
+                  <a:txBody>
+                    <a:bodyPr/>
+                    <a:lstStyle/>
+                    <a:p>
+                      <a:pPr algn="ctr" indent="0" marL="0">
+                        <a:buNone/>
+                      </a:pPr>
+                      <a:r>
+                        <a:rPr lang="en-US" sz="1100" dirty="0">
+                          <a:solidFill>
+                            <a:srgbClr val="17233B"/>
+                          </a:solidFill>
+                          <a:latin typeface="Calibri" pitchFamily="34" charset="0"/>
+                          <a:ea typeface="Calibri" pitchFamily="34" charset="-122"/>
+                          <a:cs typeface="Calibri" pitchFamily="34" charset="-120"/>
+                        </a:rPr>
+                        <a:t>8</a:t>
+                      </a:r>
+                      <a:endParaRPr lang="en-US" sz="1100" dirty="0">
+                        <a:latin typeface="Calibri" charset="0"/>
+                        <a:ea typeface="Calibri" charset="0"/>
+                        <a:cs typeface="Calibri" charset="0"/>
+                      </a:endParaRPr>
+                    </a:p>
+                  </a:txBody>
+                  <a:tcPr marL="91440" marR="91440" marT="45720" marB="45720" anchor="ctr">
+                    <a:lnL w="6350" cap="flat" cmpd="sng" algn="ctr">
+                      <a:solidFill>
+                        <a:srgbClr val="E9EEF5"/>
+                      </a:solidFill>
+                      <a:prstDash val="solid"/>
+                      <a:round/>
+                      <a:headEnd type="none" w="med" len="med"/>
+                      <a:tailEnd type="none" w="med" len="med"/>
+                    </a:lnL>
+                    <a:lnR w="6350" cap="flat" cmpd="sng" algn="ctr">
+                      <a:solidFill>
+                        <a:srgbClr val="E9EEF5"/>
+                      </a:solidFill>
+                      <a:prstDash val="solid"/>
+                      <a:round/>
+                      <a:headEnd type="none" w="med" len="med"/>
+                      <a:tailEnd type="none" w="med" len="med"/>
+                    </a:lnR>
+                    <a:lnT w="6350" cap="flat" cmpd="sng" algn="ctr">
+                      <a:solidFill>
+                        <a:srgbClr val="E9EEF5"/>
+                      </a:solidFill>
+                      <a:prstDash val="solid"/>
+                      <a:round/>
+                      <a:headEnd type="none" w="med" len="med"/>
+                      <a:tailEnd type="none" w="med" len="med"/>
+                    </a:lnT>
+                    <a:lnB w="6350" cap="flat" cmpd="sng" algn="ctr">
+                      <a:solidFill>
+                        <a:srgbClr val="E9EEF5"/>
+                      </a:solidFill>
+                      <a:prstDash val="solid"/>
+                      <a:round/>
+                      <a:headEnd type="none" w="med" len="med"/>
+                      <a:tailEnd type="none" w="med" len="med"/>
+                    </a:lnB>
+                  </a:tcPr>
+                </a:tc>
+                <a:tc>
+                  <a:txBody>
+                    <a:bodyPr/>
+                    <a:lstStyle/>
+                    <a:p>
+                      <a:pPr algn="ctr" indent="0" marL="0">
+                        <a:buNone/>
+                      </a:pPr>
+                      <a:r>
+                        <a:rPr lang="en-US" sz="1100" dirty="0">
+                          <a:solidFill>
+                            <a:srgbClr val="17233B"/>
+                          </a:solidFill>
+                          <a:latin typeface="Calibri" pitchFamily="34" charset="0"/>
+                          <a:ea typeface="Calibri" pitchFamily="34" charset="-122"/>
+                          <a:cs typeface="Calibri" pitchFamily="34" charset="-120"/>
+                        </a:rPr>
+                        <a:t>2</a:t>
+                      </a:r>
+                      <a:endParaRPr lang="en-US" sz="1100" dirty="0">
+                        <a:latin typeface="Calibri" charset="0"/>
+                        <a:ea typeface="Calibri" charset="0"/>
+                        <a:cs typeface="Calibri" charset="0"/>
+                      </a:endParaRPr>
+                    </a:p>
+                  </a:txBody>
+                  <a:tcPr marL="91440" marR="91440" marT="45720" marB="45720" anchor="ctr">
+                    <a:lnL w="6350" cap="flat" cmpd="sng" algn="ctr">
+                      <a:solidFill>
+                        <a:srgbClr val="E9EEF5"/>
+                      </a:solidFill>
+                      <a:prstDash val="solid"/>
+                      <a:round/>
+                      <a:headEnd type="none" w="med" len="med"/>
+                      <a:tailEnd type="none" w="med" len="med"/>
+                    </a:lnL>
+                    <a:lnR w="6350" cap="flat" cmpd="sng" algn="ctr">
+                      <a:solidFill>
+                        <a:srgbClr val="E9EEF5"/>
+                      </a:solidFill>
+                      <a:prstDash val="solid"/>
+                      <a:round/>
+                      <a:headEnd type="none" w="med" len="med"/>
+                      <a:tailEnd type="none" w="med" len="med"/>
+                    </a:lnR>
+                    <a:lnT w="6350" cap="flat" cmpd="sng" algn="ctr">
+                      <a:solidFill>
+                        <a:srgbClr val="E9EEF5"/>
+                      </a:solidFill>
+                      <a:prstDash val="solid"/>
+                      <a:round/>
+                      <a:headEnd type="none" w="med" len="med"/>
+                      <a:tailEnd type="none" w="med" len="med"/>
+                    </a:lnT>
+                    <a:lnB w="6350" cap="flat" cmpd="sng" algn="ctr">
+                      <a:solidFill>
+                        <a:srgbClr val="E9EEF5"/>
+                      </a:solidFill>
+                      <a:prstDash val="solid"/>
+                      <a:round/>
+                      <a:headEnd type="none" w="med" len="med"/>
+                      <a:tailEnd type="none" w="med" len="med"/>
+                    </a:lnB>
+                  </a:tcPr>
+                </a:tc>
+                <a:tc>
+                  <a:txBody>
+                    <a:bodyPr/>
+                    <a:lstStyle/>
+                    <a:p>
+                      <a:pPr algn="ctr" indent="0" marL="0">
+                        <a:buNone/>
+                      </a:pPr>
+                      <a:r>
+                        <a:rPr lang="en-US" sz="1100" dirty="0">
+                          <a:solidFill>
+                            <a:srgbClr val="17233B"/>
+                          </a:solidFill>
+                          <a:latin typeface="Calibri" pitchFamily="34" charset="0"/>
+                          <a:ea typeface="Calibri" pitchFamily="34" charset="-122"/>
+                          <a:cs typeface="Calibri" pitchFamily="34" charset="-120"/>
+                        </a:rPr>
+                        <a:t>—</a:t>
+                      </a:r>
+                      <a:endParaRPr lang="en-US" sz="1100" dirty="0">
+                        <a:latin typeface="Calibri" charset="0"/>
+                        <a:ea typeface="Calibri" charset="0"/>
+                        <a:cs typeface="Calibri" charset="0"/>
+                      </a:endParaRPr>
+                    </a:p>
+                  </a:txBody>
+                  <a:tcPr marL="91440" marR="91440" marT="45720" marB="45720" anchor="ctr">
+                    <a:lnL w="6350" cap="flat" cmpd="sng" algn="ctr">
+                      <a:solidFill>
+                        <a:srgbClr val="E9EEF5"/>
+                      </a:solidFill>
+                      <a:prstDash val="solid"/>
+                      <a:round/>
+                      <a:headEnd type="none" w="med" len="med"/>
+                      <a:tailEnd type="none" w="med" len="med"/>
+                    </a:lnL>
+                    <a:lnR w="6350" cap="flat" cmpd="sng" algn="ctr">
+                      <a:solidFill>
+                        <a:srgbClr val="E9EEF5"/>
+                      </a:solidFill>
+                      <a:prstDash val="solid"/>
+                      <a:round/>
+                      <a:headEnd type="none" w="med" len="med"/>
+                      <a:tailEnd type="none" w="med" len="med"/>
+                    </a:lnR>
+                    <a:lnT w="6350" cap="flat" cmpd="sng" algn="ctr">
+                      <a:solidFill>
+                        <a:srgbClr val="E9EEF5"/>
+                      </a:solidFill>
+                      <a:prstDash val="solid"/>
+                      <a:round/>
+                      <a:headEnd type="none" w="med" len="med"/>
+                      <a:tailEnd type="none" w="med" len="med"/>
+                    </a:lnT>
+                    <a:lnB w="6350" cap="flat" cmpd="sng" algn="ctr">
+                      <a:solidFill>
+                        <a:srgbClr val="E9EEF5"/>
+                      </a:solidFill>
+                      <a:prstDash val="solid"/>
+                      <a:round/>
+                      <a:headEnd type="none" w="med" len="med"/>
+                      <a:tailEnd type="none" w="med" len="med"/>
+                    </a:lnB>
+                  </a:tcPr>
+                </a:tc>
+                <a:tc>
+                  <a:txBody>
+                    <a:bodyPr/>
+                    <a:lstStyle/>
+                    <a:p>
+                      <a:pPr algn="ctr" indent="0" marL="0">
+                        <a:buNone/>
+                      </a:pPr>
+                      <a:r>
+                        <a:rPr lang="en-US" sz="1050" b="1" dirty="0">
+                          <a:solidFill>
+                            <a:srgbClr val="B45309"/>
+                          </a:solidFill>
+                          <a:latin typeface="Calibri" pitchFamily="34" charset="0"/>
+                          <a:ea typeface="Calibri" pitchFamily="34" charset="-122"/>
+                          <a:cs typeface="Calibri" pitchFamily="34" charset="-120"/>
+                        </a:rPr>
+                        <a:t>Review</a:t>
+                      </a:r>
+                      <a:endParaRPr lang="en-US" sz="1050" dirty="0">
+                        <a:latin typeface="Calibri" charset="0"/>
+                        <a:ea typeface="Calibri" charset="0"/>
+                        <a:cs typeface="Calibri" charset="0"/>
+                      </a:endParaRPr>
+                    </a:p>
+                  </a:txBody>
+                  <a:tcPr marL="91440" marR="91440" marT="45720" marB="45720" anchor="ctr">
+                    <a:lnL w="6350" cap="flat" cmpd="sng" algn="ctr">
+                      <a:solidFill>
+                        <a:srgbClr val="E9EEF5"/>
+                      </a:solidFill>
+                      <a:prstDash val="solid"/>
+                      <a:round/>
+                      <a:headEnd type="none" w="med" len="med"/>
+                      <a:tailEnd type="none" w="med" len="med"/>
+                    </a:lnL>
+                    <a:lnR w="6350" cap="flat" cmpd="sng" algn="ctr">
+                      <a:solidFill>
+                        <a:srgbClr val="E9EEF5"/>
+                      </a:solidFill>
+                      <a:prstDash val="solid"/>
+                      <a:round/>
+                      <a:headEnd type="none" w="med" len="med"/>
+                      <a:tailEnd type="none" w="med" len="med"/>
+                    </a:lnR>
+                    <a:lnT w="6350" cap="flat" cmpd="sng" algn="ctr">
+                      <a:solidFill>
+                        <a:srgbClr val="E9EEF5"/>
+                      </a:solidFill>
+                      <a:prstDash val="solid"/>
+                      <a:round/>
+                      <a:headEnd type="none" w="med" len="med"/>
+                      <a:tailEnd type="none" w="med" len="med"/>
+                    </a:lnT>
+                    <a:lnB w="6350" cap="flat" cmpd="sng" algn="ctr">
+                      <a:solidFill>
+                        <a:srgbClr val="E9EEF5"/>
+                      </a:solidFill>
+                      <a:prstDash val="solid"/>
+                      <a:round/>
+                      <a:headEnd type="none" w="med" len="med"/>
+                      <a:tailEnd type="none" w="med" len="med"/>
+                    </a:lnB>
+                    <a:solidFill>
+                      <a:srgbClr val="FEF3C7"/>
+                    </a:solidFill>
+                  </a:tcPr>
+                </a:tc>
+              </a:tr>
+              <a:tr h="329184">
+                <a:tc>
+                  <a:txBody>
+                    <a:bodyPr/>
+                    <a:lstStyle/>
+                    <a:p>
+                      <a:pPr algn="l" indent="0" marL="0">
+                        <a:buNone/>
+                      </a:pPr>
+                      <a:r>
+                        <a:rPr lang="en-US" sz="1100" dirty="0">
+                          <a:solidFill>
+                            <a:srgbClr val="17233B"/>
+                          </a:solidFill>
+                          <a:latin typeface="Calibri" pitchFamily="34" charset="0"/>
+                          <a:ea typeface="Calibri" pitchFamily="34" charset="-122"/>
+                          <a:cs typeface="Calibri" pitchFamily="34" charset="-120"/>
+                        </a:rPr>
+                        <a:t>spl-secure</a:t>
+                      </a:r>
+                      <a:endParaRPr lang="en-US" sz="1100" dirty="0">
+                        <a:latin typeface="Calibri" charset="0"/>
+                        <a:ea typeface="Calibri" charset="0"/>
+                        <a:cs typeface="Calibri" charset="0"/>
+                      </a:endParaRPr>
+                    </a:p>
+                  </a:txBody>
+                  <a:tcPr marL="91440" marR="91440" marT="45720" marB="45720" anchor="ctr">
+                    <a:lnL w="6350" cap="flat" cmpd="sng" algn="ctr">
+                      <a:solidFill>
+                        <a:srgbClr val="E9EEF5"/>
+                      </a:solidFill>
+                      <a:prstDash val="solid"/>
+                      <a:round/>
+                      <a:headEnd type="none" w="med" len="med"/>
+                      <a:tailEnd type="none" w="med" len="med"/>
+                    </a:lnL>
+                    <a:lnR w="6350" cap="flat" cmpd="sng" algn="ctr">
+                      <a:solidFill>
+                        <a:srgbClr val="E9EEF5"/>
+                      </a:solidFill>
+                      <a:prstDash val="solid"/>
+                      <a:round/>
+                      <a:headEnd type="none" w="med" len="med"/>
+                      <a:tailEnd type="none" w="med" len="med"/>
+                    </a:lnR>
+                    <a:lnT w="6350" cap="flat" cmpd="sng" algn="ctr">
+                      <a:solidFill>
+                        <a:srgbClr val="E9EEF5"/>
+                      </a:solidFill>
+                      <a:prstDash val="solid"/>
+                      <a:round/>
+                      <a:headEnd type="none" w="med" len="med"/>
+                      <a:tailEnd type="none" w="med" len="med"/>
+                    </a:lnT>
+                    <a:lnB w="6350" cap="flat" cmpd="sng" algn="ctr">
+                      <a:solidFill>
+                        <a:srgbClr val="E9EEF5"/>
+                      </a:solidFill>
+                      <a:prstDash val="solid"/>
+                      <a:round/>
+                      <a:headEnd type="none" w="med" len="med"/>
+                      <a:tailEnd type="none" w="med" len="med"/>
+                    </a:lnB>
+                  </a:tcPr>
+                </a:tc>
+                <a:tc>
+                  <a:txBody>
+                    <a:bodyPr/>
+                    <a:lstStyle/>
+                    <a:p>
+                      <a:pPr algn="ctr" indent="0" marL="0">
+                        <a:buNone/>
+                      </a:pPr>
+                      <a:r>
+                        <a:rPr lang="en-US" sz="1100" dirty="0">
+                          <a:solidFill>
+                            <a:srgbClr val="17233B"/>
+                          </a:solidFill>
+                          <a:latin typeface="Calibri" pitchFamily="34" charset="0"/>
+                          <a:ea typeface="Calibri" pitchFamily="34" charset="-122"/>
+                          <a:cs typeface="Calibri" pitchFamily="34" charset="-120"/>
+                        </a:rPr>
+                        <a:t>8</a:t>
+                      </a:r>
+                      <a:endParaRPr lang="en-US" sz="1100" dirty="0">
+                        <a:latin typeface="Calibri" charset="0"/>
+                        <a:ea typeface="Calibri" charset="0"/>
+                        <a:cs typeface="Calibri" charset="0"/>
+                      </a:endParaRPr>
+                    </a:p>
+                  </a:txBody>
+                  <a:tcPr marL="91440" marR="91440" marT="45720" marB="45720" anchor="ctr">
+                    <a:lnL w="6350" cap="flat" cmpd="sng" algn="ctr">
+                      <a:solidFill>
+                        <a:srgbClr val="E9EEF5"/>
+                      </a:solidFill>
+                      <a:prstDash val="solid"/>
+                      <a:round/>
+                      <a:headEnd type="none" w="med" len="med"/>
+                      <a:tailEnd type="none" w="med" len="med"/>
+                    </a:lnL>
+                    <a:lnR w="6350" cap="flat" cmpd="sng" algn="ctr">
+                      <a:solidFill>
+                        <a:srgbClr val="E9EEF5"/>
+                      </a:solidFill>
+                      <a:prstDash val="solid"/>
+                      <a:round/>
+                      <a:headEnd type="none" w="med" len="med"/>
+                      <a:tailEnd type="none" w="med" len="med"/>
+                    </a:lnR>
+                    <a:lnT w="6350" cap="flat" cmpd="sng" algn="ctr">
+                      <a:solidFill>
+                        <a:srgbClr val="E9EEF5"/>
+                      </a:solidFill>
+                      <a:prstDash val="solid"/>
+                      <a:round/>
+                      <a:headEnd type="none" w="med" len="med"/>
+                      <a:tailEnd type="none" w="med" len="med"/>
+                    </a:lnT>
+                    <a:lnB w="6350" cap="flat" cmpd="sng" algn="ctr">
+                      <a:solidFill>
+                        <a:srgbClr val="E9EEF5"/>
+                      </a:solidFill>
+                      <a:prstDash val="solid"/>
+                      <a:round/>
+                      <a:headEnd type="none" w="med" len="med"/>
+                      <a:tailEnd type="none" w="med" len="med"/>
+                    </a:lnB>
+                  </a:tcPr>
+                </a:tc>
+                <a:tc>
+                  <a:txBody>
+                    <a:bodyPr/>
+                    <a:lstStyle/>
+                    <a:p>
+                      <a:pPr algn="ctr" indent="0" marL="0">
+                        <a:buNone/>
+                      </a:pPr>
+                      <a:r>
+                        <a:rPr lang="en-US" sz="1100" dirty="0">
+                          <a:solidFill>
+                            <a:srgbClr val="17233B"/>
+                          </a:solidFill>
+                          <a:latin typeface="Calibri" pitchFamily="34" charset="0"/>
+                          <a:ea typeface="Calibri" pitchFamily="34" charset="-122"/>
+                          <a:cs typeface="Calibri" pitchFamily="34" charset="-120"/>
+                        </a:rPr>
+                        <a:t>3</a:t>
+                      </a:r>
+                      <a:endParaRPr lang="en-US" sz="1100" dirty="0">
+                        <a:latin typeface="Calibri" charset="0"/>
+                        <a:ea typeface="Calibri" charset="0"/>
+                        <a:cs typeface="Calibri" charset="0"/>
+                      </a:endParaRPr>
+                    </a:p>
+                  </a:txBody>
+                  <a:tcPr marL="91440" marR="91440" marT="45720" marB="45720" anchor="ctr">
+                    <a:lnL w="6350" cap="flat" cmpd="sng" algn="ctr">
+                      <a:solidFill>
+                        <a:srgbClr val="E9EEF5"/>
+                      </a:solidFill>
+                      <a:prstDash val="solid"/>
+                      <a:round/>
+                      <a:headEnd type="none" w="med" len="med"/>
+                      <a:tailEnd type="none" w="med" len="med"/>
+                    </a:lnL>
+                    <a:lnR w="6350" cap="flat" cmpd="sng" algn="ctr">
+                      <a:solidFill>
+                        <a:srgbClr val="E9EEF5"/>
+                      </a:solidFill>
+                      <a:prstDash val="solid"/>
+                      <a:round/>
+                      <a:headEnd type="none" w="med" len="med"/>
+                      <a:tailEnd type="none" w="med" len="med"/>
+                    </a:lnR>
+                    <a:lnT w="6350" cap="flat" cmpd="sng" algn="ctr">
+                      <a:solidFill>
+                        <a:srgbClr val="E9EEF5"/>
+                      </a:solidFill>
+                      <a:prstDash val="solid"/>
+                      <a:round/>
+                      <a:headEnd type="none" w="med" len="med"/>
+                      <a:tailEnd type="none" w="med" len="med"/>
+                    </a:lnT>
+                    <a:lnB w="6350" cap="flat" cmpd="sng" algn="ctr">
+                      <a:solidFill>
+                        <a:srgbClr val="E9EEF5"/>
+                      </a:solidFill>
+                      <a:prstDash val="solid"/>
+                      <a:round/>
+                      <a:headEnd type="none" w="med" len="med"/>
+                      <a:tailEnd type="none" w="med" len="med"/>
+                    </a:lnB>
+                  </a:tcPr>
+                </a:tc>
+                <a:tc>
+                  <a:txBody>
+                    <a:bodyPr/>
+                    <a:lstStyle/>
+                    <a:p>
+                      <a:pPr algn="ctr" indent="0" marL="0">
+                        <a:buNone/>
+                      </a:pPr>
+                      <a:r>
+                        <a:rPr lang="en-US" sz="1100" dirty="0">
+                          <a:solidFill>
+                            <a:srgbClr val="17233B"/>
+                          </a:solidFill>
+                          <a:latin typeface="Calibri" pitchFamily="34" charset="0"/>
+                          <a:ea typeface="Calibri" pitchFamily="34" charset="-122"/>
+                          <a:cs typeface="Calibri" pitchFamily="34" charset="-120"/>
+                        </a:rPr>
+                        <a:t>5</a:t>
+                      </a:r>
+                      <a:endParaRPr lang="en-US" sz="1100" dirty="0">
+                        <a:latin typeface="Calibri" charset="0"/>
+                        <a:ea typeface="Calibri" charset="0"/>
+                        <a:cs typeface="Calibri" charset="0"/>
+                      </a:endParaRPr>
+                    </a:p>
+                  </a:txBody>
+                  <a:tcPr marL="91440" marR="91440" marT="45720" marB="45720" anchor="ctr">
+                    <a:lnL w="6350" cap="flat" cmpd="sng" algn="ctr">
+                      <a:solidFill>
+                        <a:srgbClr val="E9EEF5"/>
+                      </a:solidFill>
+                      <a:prstDash val="solid"/>
+                      <a:round/>
+                      <a:headEnd type="none" w="med" len="med"/>
+                      <a:tailEnd type="none" w="med" len="med"/>
+                    </a:lnL>
+                    <a:lnR w="6350" cap="flat" cmpd="sng" algn="ctr">
+                      <a:solidFill>
+                        <a:srgbClr val="E9EEF5"/>
+                      </a:solidFill>
+                      <a:prstDash val="solid"/>
+                      <a:round/>
+                      <a:headEnd type="none" w="med" len="med"/>
+                      <a:tailEnd type="none" w="med" len="med"/>
+                    </a:lnR>
+                    <a:lnT w="6350" cap="flat" cmpd="sng" algn="ctr">
+                      <a:solidFill>
+                        <a:srgbClr val="E9EEF5"/>
+                      </a:solidFill>
+                      <a:prstDash val="solid"/>
+                      <a:round/>
+                      <a:headEnd type="none" w="med" len="med"/>
+                      <a:tailEnd type="none" w="med" len="med"/>
+                    </a:lnT>
+                    <a:lnB w="6350" cap="flat" cmpd="sng" algn="ctr">
+                      <a:solidFill>
+                        <a:srgbClr val="E9EEF5"/>
+                      </a:solidFill>
+                      <a:prstDash val="solid"/>
+                      <a:round/>
+                      <a:headEnd type="none" w="med" len="med"/>
+                      <a:tailEnd type="none" w="med" len="med"/>
+                    </a:lnB>
+                  </a:tcPr>
+                </a:tc>
+                <a:tc>
+                  <a:txBody>
+                    <a:bodyPr/>
+                    <a:lstStyle/>
+                    <a:p>
+                      <a:pPr algn="ctr" indent="0" marL="0">
+                        <a:buNone/>
+                      </a:pPr>
+                      <a:r>
+                        <a:rPr lang="en-US" sz="1100" dirty="0">
+                          <a:solidFill>
+                            <a:srgbClr val="17233B"/>
+                          </a:solidFill>
+                          <a:latin typeface="Calibri" pitchFamily="34" charset="0"/>
+                          <a:ea typeface="Calibri" pitchFamily="34" charset="-122"/>
+                          <a:cs typeface="Calibri" pitchFamily="34" charset="-120"/>
+                        </a:rPr>
+                        <a:t>—</a:t>
+                      </a:r>
+                      <a:endParaRPr lang="en-US" sz="1100" dirty="0">
+                        <a:latin typeface="Calibri" charset="0"/>
+                        <a:ea typeface="Calibri" charset="0"/>
+                        <a:cs typeface="Calibri" charset="0"/>
+                      </a:endParaRPr>
+                    </a:p>
+                  </a:txBody>
+                  <a:tcPr marL="91440" marR="91440" marT="45720" marB="45720" anchor="ctr">
+                    <a:lnL w="6350" cap="flat" cmpd="sng" algn="ctr">
+                      <a:solidFill>
+                        <a:srgbClr val="E9EEF5"/>
+                      </a:solidFill>
+                      <a:prstDash val="solid"/>
+                      <a:round/>
+                      <a:headEnd type="none" w="med" len="med"/>
+                      <a:tailEnd type="none" w="med" len="med"/>
+                    </a:lnL>
+                    <a:lnR w="6350" cap="flat" cmpd="sng" algn="ctr">
+                      <a:solidFill>
+                        <a:srgbClr val="E9EEF5"/>
+                      </a:solidFill>
+                      <a:prstDash val="solid"/>
+                      <a:round/>
+                      <a:headEnd type="none" w="med" len="med"/>
+                      <a:tailEnd type="none" w="med" len="med"/>
+                    </a:lnR>
+                    <a:lnT w="6350" cap="flat" cmpd="sng" algn="ctr">
+                      <a:solidFill>
+                        <a:srgbClr val="E9EEF5"/>
+                      </a:solidFill>
+                      <a:prstDash val="solid"/>
+                      <a:round/>
+                      <a:headEnd type="none" w="med" len="med"/>
+                      <a:tailEnd type="none" w="med" len="med"/>
+                    </a:lnT>
+                    <a:lnB w="6350" cap="flat" cmpd="sng" algn="ctr">
+                      <a:solidFill>
+                        <a:srgbClr val="E9EEF5"/>
+                      </a:solidFill>
+                      <a:prstDash val="solid"/>
+                      <a:round/>
+                      <a:headEnd type="none" w="med" len="med"/>
+                      <a:tailEnd type="none" w="med" len="med"/>
+                    </a:lnB>
+                  </a:tcPr>
+                </a:tc>
+                <a:tc>
+                  <a:txBody>
+                    <a:bodyPr/>
+                    <a:lstStyle/>
+                    <a:p>
+                      <a:pPr algn="ctr" indent="0" marL="0">
+                        <a:buNone/>
+                      </a:pPr>
+                      <a:r>
+                        <a:rPr lang="en-US" sz="1050" b="1" dirty="0">
+                          <a:solidFill>
+                            <a:srgbClr val="B45309"/>
+                          </a:solidFill>
+                          <a:latin typeface="Calibri" pitchFamily="34" charset="0"/>
+                          <a:ea typeface="Calibri" pitchFamily="34" charset="-122"/>
+                          <a:cs typeface="Calibri" pitchFamily="34" charset="-120"/>
+                        </a:rPr>
+                        <a:t>Review</a:t>
+                      </a:r>
+                      <a:endParaRPr lang="en-US" sz="1050" dirty="0">
+                        <a:latin typeface="Calibri" charset="0"/>
+                        <a:ea typeface="Calibri" charset="0"/>
+                        <a:cs typeface="Calibri" charset="0"/>
+                      </a:endParaRPr>
+                    </a:p>
+                  </a:txBody>
+                  <a:tcPr marL="91440" marR="91440" marT="45720" marB="45720" anchor="ctr">
+                    <a:lnL w="6350" cap="flat" cmpd="sng" algn="ctr">
+                      <a:solidFill>
+                        <a:srgbClr val="E9EEF5"/>
+                      </a:solidFill>
+                      <a:prstDash val="solid"/>
+                      <a:round/>
+                      <a:headEnd type="none" w="med" len="med"/>
+                      <a:tailEnd type="none" w="med" len="med"/>
+                    </a:lnL>
+                    <a:lnR w="6350" cap="flat" cmpd="sng" algn="ctr">
+                      <a:solidFill>
+                        <a:srgbClr val="E9EEF5"/>
+                      </a:solidFill>
+                      <a:prstDash val="solid"/>
+                      <a:round/>
+                      <a:headEnd type="none" w="med" len="med"/>
+                      <a:tailEnd type="none" w="med" len="med"/>
+                    </a:lnR>
+                    <a:lnT w="6350" cap="flat" cmpd="sng" algn="ctr">
+                      <a:solidFill>
+                        <a:srgbClr val="E9EEF5"/>
+                      </a:solidFill>
+                      <a:prstDash val="solid"/>
+                      <a:round/>
+                      <a:headEnd type="none" w="med" len="med"/>
+                      <a:tailEnd type="none" w="med" len="med"/>
+                    </a:lnT>
+                    <a:lnB w="6350" cap="flat" cmpd="sng" algn="ctr">
+                      <a:solidFill>
+                        <a:srgbClr val="E9EEF5"/>
+                      </a:solidFill>
+                      <a:prstDash val="solid"/>
+                      <a:round/>
+                      <a:headEnd type="none" w="med" len="med"/>
+                      <a:tailEnd type="none" w="med" len="med"/>
+                    </a:lnB>
+                    <a:solidFill>
+                      <a:srgbClr val="FEF3C7"/>
+                    </a:solidFill>
+                  </a:tcPr>
+                </a:tc>
+              </a:tr>
+              <a:tr h="329184">
+                <a:tc>
+                  <a:txBody>
+                    <a:bodyPr/>
+                    <a:lstStyle/>
+                    <a:p>
+                      <a:pPr algn="l" indent="0" marL="0">
+                        <a:buNone/>
+                      </a:pPr>
+                      <a:r>
+                        <a:rPr lang="en-US" sz="1100" dirty="0">
+                          <a:solidFill>
+                            <a:srgbClr val="17233B"/>
+                          </a:solidFill>
+                          <a:latin typeface="Calibri" pitchFamily="34" charset="0"/>
+                          <a:ea typeface="Calibri" pitchFamily="34" charset="-122"/>
+                          <a:cs typeface="Calibri" pitchFamily="34" charset="-120"/>
+                        </a:rPr>
+                        <a:t>spl-edp</a:t>
+                      </a:r>
+                      <a:endParaRPr lang="en-US" sz="1100" dirty="0">
+                        <a:latin typeface="Calibri" charset="0"/>
+                        <a:ea typeface="Calibri" charset="0"/>
+                        <a:cs typeface="Calibri" charset="0"/>
+                      </a:endParaRPr>
+                    </a:p>
+                  </a:txBody>
+                  <a:tcPr marL="91440" marR="91440" marT="45720" marB="45720" anchor="ctr">
+                    <a:lnL w="6350" cap="flat" cmpd="sng" algn="ctr">
+                      <a:solidFill>
+                        <a:srgbClr val="E9EEF5"/>
+                      </a:solidFill>
+                      <a:prstDash val="solid"/>
+                      <a:round/>
+                      <a:headEnd type="none" w="med" len="med"/>
+                      <a:tailEnd type="none" w="med" len="med"/>
+                    </a:lnL>
+                    <a:lnR w="6350" cap="flat" cmpd="sng" algn="ctr">
+                      <a:solidFill>
+                        <a:srgbClr val="E9EEF5"/>
+                      </a:solidFill>
+                      <a:prstDash val="solid"/>
+                      <a:round/>
+                      <a:headEnd type="none" w="med" len="med"/>
+                      <a:tailEnd type="none" w="med" len="med"/>
+                    </a:lnR>
+                    <a:lnT w="6350" cap="flat" cmpd="sng" algn="ctr">
+                      <a:solidFill>
+                        <a:srgbClr val="E9EEF5"/>
+                      </a:solidFill>
+                      <a:prstDash val="solid"/>
+                      <a:round/>
+                      <a:headEnd type="none" w="med" len="med"/>
+                      <a:tailEnd type="none" w="med" len="med"/>
+                    </a:lnT>
+                    <a:lnB w="6350" cap="flat" cmpd="sng" algn="ctr">
+                      <a:solidFill>
+                        <a:srgbClr val="E9EEF5"/>
+                      </a:solidFill>
+                      <a:prstDash val="solid"/>
+                      <a:round/>
+                      <a:headEnd type="none" w="med" len="med"/>
+                      <a:tailEnd type="none" w="med" len="med"/>
+                    </a:lnB>
+                  </a:tcPr>
+                </a:tc>
+                <a:tc>
+                  <a:txBody>
+                    <a:bodyPr/>
+                    <a:lstStyle/>
+                    <a:p>
+                      <a:pPr algn="ctr" indent="0" marL="0">
+                        <a:buNone/>
+                      </a:pPr>
+                      <a:r>
+                        <a:rPr lang="en-US" sz="1100" dirty="0">
+                          <a:solidFill>
+                            <a:srgbClr val="17233B"/>
+                          </a:solidFill>
+                          <a:latin typeface="Calibri" pitchFamily="34" charset="0"/>
+                          <a:ea typeface="Calibri" pitchFamily="34" charset="-122"/>
+                          <a:cs typeface="Calibri" pitchFamily="34" charset="-120"/>
+                        </a:rPr>
+                        <a:t>14</a:t>
+                      </a:r>
+                      <a:endParaRPr lang="en-US" sz="1100" dirty="0">
+                        <a:latin typeface="Calibri" charset="0"/>
+                        <a:ea typeface="Calibri" charset="0"/>
+                        <a:cs typeface="Calibri" charset="0"/>
+                      </a:endParaRPr>
+                    </a:p>
+                  </a:txBody>
+                  <a:tcPr marL="91440" marR="91440" marT="45720" marB="45720" anchor="ctr">
+                    <a:lnL w="6350" cap="flat" cmpd="sng" algn="ctr">
+                      <a:solidFill>
+                        <a:srgbClr val="E9EEF5"/>
+                      </a:solidFill>
+                      <a:prstDash val="solid"/>
+                      <a:round/>
+                      <a:headEnd type="none" w="med" len="med"/>
+                      <a:tailEnd type="none" w="med" len="med"/>
+                    </a:lnL>
+                    <a:lnR w="6350" cap="flat" cmpd="sng" algn="ctr">
+                      <a:solidFill>
+                        <a:srgbClr val="E9EEF5"/>
+                      </a:solidFill>
+                      <a:prstDash val="solid"/>
+                      <a:round/>
+                      <a:headEnd type="none" w="med" len="med"/>
+                      <a:tailEnd type="none" w="med" len="med"/>
+                    </a:lnR>
+                    <a:lnT w="6350" cap="flat" cmpd="sng" algn="ctr">
+                      <a:solidFill>
+                        <a:srgbClr val="E9EEF5"/>
+                      </a:solidFill>
+                      <a:prstDash val="solid"/>
+                      <a:round/>
+                      <a:headEnd type="none" w="med" len="med"/>
+                      <a:tailEnd type="none" w="med" len="med"/>
+                    </a:lnT>
+                    <a:lnB w="6350" cap="flat" cmpd="sng" algn="ctr">
+                      <a:solidFill>
+                        <a:srgbClr val="E9EEF5"/>
+                      </a:solidFill>
+                      <a:prstDash val="solid"/>
+                      <a:round/>
+                      <a:headEnd type="none" w="med" len="med"/>
+                      <a:tailEnd type="none" w="med" len="med"/>
+                    </a:lnB>
+                  </a:tcPr>
+                </a:tc>
+                <a:tc>
+                  <a:txBody>
+                    <a:bodyPr/>
+                    <a:lstStyle/>
+                    <a:p>
+                      <a:pPr algn="ctr" indent="0" marL="0">
+                        <a:buNone/>
+                      </a:pPr>
+                      <a:r>
+                        <a:rPr lang="en-US" sz="1100" dirty="0">
+                          <a:solidFill>
+                            <a:srgbClr val="17233B"/>
+                          </a:solidFill>
+                          <a:latin typeface="Calibri" pitchFamily="34" charset="0"/>
+                          <a:ea typeface="Calibri" pitchFamily="34" charset="-122"/>
+                          <a:cs typeface="Calibri" pitchFamily="34" charset="-120"/>
+                        </a:rPr>
+                        <a:t>14</a:t>
+                      </a:r>
+                      <a:endParaRPr lang="en-US" sz="1100" dirty="0">
+                        <a:latin typeface="Calibri" charset="0"/>
+                        <a:ea typeface="Calibri" charset="0"/>
+                        <a:cs typeface="Calibri" charset="0"/>
+                      </a:endParaRPr>
+                    </a:p>
+                  </a:txBody>
+                  <a:tcPr marL="91440" marR="91440" marT="45720" marB="45720" anchor="ctr">
+                    <a:lnL w="6350" cap="flat" cmpd="sng" algn="ctr">
+                      <a:solidFill>
+                        <a:srgbClr val="E9EEF5"/>
+                      </a:solidFill>
+                      <a:prstDash val="solid"/>
+                      <a:round/>
+                      <a:headEnd type="none" w="med" len="med"/>
+                      <a:tailEnd type="none" w="med" len="med"/>
+                    </a:lnL>
+                    <a:lnR w="6350" cap="flat" cmpd="sng" algn="ctr">
+                      <a:solidFill>
+                        <a:srgbClr val="E9EEF5"/>
+                      </a:solidFill>
+                      <a:prstDash val="solid"/>
+                      <a:round/>
+                      <a:headEnd type="none" w="med" len="med"/>
+                      <a:tailEnd type="none" w="med" len="med"/>
+                    </a:lnR>
+                    <a:lnT w="6350" cap="flat" cmpd="sng" algn="ctr">
+                      <a:solidFill>
+                        <a:srgbClr val="E9EEF5"/>
+                      </a:solidFill>
+                      <a:prstDash val="solid"/>
+                      <a:round/>
+                      <a:headEnd type="none" w="med" len="med"/>
+                      <a:tailEnd type="none" w="med" len="med"/>
+                    </a:lnT>
+                    <a:lnB w="6350" cap="flat" cmpd="sng" algn="ctr">
+                      <a:solidFill>
+                        <a:srgbClr val="E9EEF5"/>
+                      </a:solidFill>
+                      <a:prstDash val="solid"/>
+                      <a:round/>
+                      <a:headEnd type="none" w="med" len="med"/>
+                      <a:tailEnd type="none" w="med" len="med"/>
+                    </a:lnB>
+                  </a:tcPr>
+                </a:tc>
+                <a:tc>
+                  <a:txBody>
+                    <a:bodyPr/>
+                    <a:lstStyle/>
+                    <a:p>
+                      <a:pPr algn="ctr" indent="0" marL="0">
+                        <a:buNone/>
+                      </a:pPr>
+                      <a:r>
+                        <a:rPr lang="en-US" sz="1100" dirty="0">
+                          <a:solidFill>
+                            <a:srgbClr val="17233B"/>
+                          </a:solidFill>
+                          <a:latin typeface="Calibri" pitchFamily="34" charset="0"/>
+                          <a:ea typeface="Calibri" pitchFamily="34" charset="-122"/>
+                          <a:cs typeface="Calibri" pitchFamily="34" charset="-120"/>
+                        </a:rPr>
+                        <a:t>—</a:t>
+                      </a:r>
+                      <a:endParaRPr lang="en-US" sz="1100" dirty="0">
+                        <a:latin typeface="Calibri" charset="0"/>
+                        <a:ea typeface="Calibri" charset="0"/>
+                        <a:cs typeface="Calibri" charset="0"/>
+                      </a:endParaRPr>
+                    </a:p>
+                  </a:txBody>
+                  <a:tcPr marL="91440" marR="91440" marT="45720" marB="45720" anchor="ctr">
+                    <a:lnL w="6350" cap="flat" cmpd="sng" algn="ctr">
+                      <a:solidFill>
+                        <a:srgbClr val="E9EEF5"/>
+                      </a:solidFill>
+                      <a:prstDash val="solid"/>
+                      <a:round/>
+                      <a:headEnd type="none" w="med" len="med"/>
+                      <a:tailEnd type="none" w="med" len="med"/>
+                    </a:lnL>
+                    <a:lnR w="6350" cap="flat" cmpd="sng" algn="ctr">
+                      <a:solidFill>
+                        <a:srgbClr val="E9EEF5"/>
+                      </a:solidFill>
+                      <a:prstDash val="solid"/>
+                      <a:round/>
+                      <a:headEnd type="none" w="med" len="med"/>
+                      <a:tailEnd type="none" w="med" len="med"/>
+                    </a:lnR>
+                    <a:lnT w="6350" cap="flat" cmpd="sng" algn="ctr">
+                      <a:solidFill>
+                        <a:srgbClr val="E9EEF5"/>
+                      </a:solidFill>
+                      <a:prstDash val="solid"/>
+                      <a:round/>
+                      <a:headEnd type="none" w="med" len="med"/>
+                      <a:tailEnd type="none" w="med" len="med"/>
+                    </a:lnT>
+                    <a:lnB w="6350" cap="flat" cmpd="sng" algn="ctr">
+                      <a:solidFill>
+                        <a:srgbClr val="E9EEF5"/>
+                      </a:solidFill>
+                      <a:prstDash val="solid"/>
+                      <a:round/>
+                      <a:headEnd type="none" w="med" len="med"/>
+                      <a:tailEnd type="none" w="med" len="med"/>
+                    </a:lnB>
+                  </a:tcPr>
+                </a:tc>
+                <a:tc>
+                  <a:txBody>
+                    <a:bodyPr/>
+                    <a:lstStyle/>
+                    <a:p>
+                      <a:pPr algn="ctr" indent="0" marL="0">
+                        <a:buNone/>
+                      </a:pPr>
+                      <a:r>
+                        <a:rPr lang="en-US" sz="1100" dirty="0">
+                          <a:solidFill>
+                            <a:srgbClr val="17233B"/>
+                          </a:solidFill>
+                          <a:latin typeface="Calibri" pitchFamily="34" charset="0"/>
+                          <a:ea typeface="Calibri" pitchFamily="34" charset="-122"/>
+                          <a:cs typeface="Calibri" pitchFamily="34" charset="-120"/>
+                        </a:rPr>
+                        <a:t>—</a:t>
+                      </a:r>
+                      <a:endParaRPr lang="en-US" sz="1100" dirty="0">
+                        <a:latin typeface="Calibri" charset="0"/>
+                        <a:ea typeface="Calibri" charset="0"/>
+                        <a:cs typeface="Calibri" charset="0"/>
+                      </a:endParaRPr>
+                    </a:p>
+                  </a:txBody>
+                  <a:tcPr marL="91440" marR="91440" marT="45720" marB="45720" anchor="ctr">
+                    <a:lnL w="6350" cap="flat" cmpd="sng" algn="ctr">
+                      <a:solidFill>
+                        <a:srgbClr val="E9EEF5"/>
+                      </a:solidFill>
+                      <a:prstDash val="solid"/>
+                      <a:round/>
+                      <a:headEnd type="none" w="med" len="med"/>
+                      <a:tailEnd type="none" w="med" len="med"/>
+                    </a:lnL>
+                    <a:lnR w="6350" cap="flat" cmpd="sng" algn="ctr">
+                      <a:solidFill>
+                        <a:srgbClr val="E9EEF5"/>
+                      </a:solidFill>
+                      <a:prstDash val="solid"/>
+                      <a:round/>
+                      <a:headEnd type="none" w="med" len="med"/>
+                      <a:tailEnd type="none" w="med" len="med"/>
+                    </a:lnR>
+                    <a:lnT w="6350" cap="flat" cmpd="sng" algn="ctr">
+                      <a:solidFill>
+                        <a:srgbClr val="E9EEF5"/>
+                      </a:solidFill>
+                      <a:prstDash val="solid"/>
+                      <a:round/>
+                      <a:headEnd type="none" w="med" len="med"/>
+                      <a:tailEnd type="none" w="med" len="med"/>
+                    </a:lnT>
+                    <a:lnB w="6350" cap="flat" cmpd="sng" algn="ctr">
+                      <a:solidFill>
+                        <a:srgbClr val="E9EEF5"/>
+                      </a:solidFill>
+                      <a:prstDash val="solid"/>
+                      <a:round/>
+                      <a:headEnd type="none" w="med" len="med"/>
+                      <a:tailEnd type="none" w="med" len="med"/>
+                    </a:lnB>
+                  </a:tcPr>
+                </a:tc>
+                <a:tc>
+                  <a:txBody>
+                    <a:bodyPr/>
+                    <a:lstStyle/>
+                    <a:p>
+                      <a:pPr algn="ctr" indent="0" marL="0">
+                        <a:buNone/>
+                      </a:pPr>
+                      <a:r>
+                        <a:rPr lang="en-US" sz="1050" b="1" dirty="0">
+                          <a:solidFill>
+                            <a:srgbClr val="16A34A"/>
+                          </a:solidFill>
+                          <a:latin typeface="Calibri" pitchFamily="34" charset="0"/>
+                          <a:ea typeface="Calibri" pitchFamily="34" charset="-122"/>
+                          <a:cs typeface="Calibri" pitchFamily="34" charset="-120"/>
+                        </a:rPr>
+                        <a:t>Ready</a:t>
+                      </a:r>
+                      <a:endParaRPr lang="en-US" sz="1050" dirty="0">
+                        <a:latin typeface="Calibri" charset="0"/>
+                        <a:ea typeface="Calibri" charset="0"/>
+                        <a:cs typeface="Calibri" charset="0"/>
+                      </a:endParaRPr>
+                    </a:p>
+                  </a:txBody>
+                  <a:tcPr marL="91440" marR="91440" marT="45720" marB="45720" anchor="ctr">
+                    <a:lnL w="6350" cap="flat" cmpd="sng" algn="ctr">
+                      <a:solidFill>
+                        <a:srgbClr val="E9EEF5"/>
+                      </a:solidFill>
+                      <a:prstDash val="solid"/>
+                      <a:round/>
+                      <a:headEnd type="none" w="med" len="med"/>
+                      <a:tailEnd type="none" w="med" len="med"/>
+                    </a:lnL>
+                    <a:lnR w="6350" cap="flat" cmpd="sng" algn="ctr">
+                      <a:solidFill>
+                        <a:srgbClr val="E9EEF5"/>
+                      </a:solidFill>
+                      <a:prstDash val="solid"/>
+                      <a:round/>
+                      <a:headEnd type="none" w="med" len="med"/>
+                      <a:tailEnd type="none" w="med" len="med"/>
+                    </a:lnR>
+                    <a:lnT w="6350" cap="flat" cmpd="sng" algn="ctr">
+                      <a:solidFill>
+                        <a:srgbClr val="E9EEF5"/>
+                      </a:solidFill>
+                      <a:prstDash val="solid"/>
+                      <a:round/>
+                      <a:headEnd type="none" w="med" len="med"/>
+                      <a:tailEnd type="none" w="med" len="med"/>
+                    </a:lnT>
+                    <a:lnB w="6350" cap="flat" cmpd="sng" algn="ctr">
+                      <a:solidFill>
+                        <a:srgbClr val="E9EEF5"/>
+                      </a:solidFill>
+                      <a:prstDash val="solid"/>
+                      <a:round/>
+                      <a:headEnd type="none" w="med" len="med"/>
+                      <a:tailEnd type="none" w="med" len="med"/>
+                    </a:lnB>
+                    <a:solidFill>
+                      <a:srgbClr val="DCFCE7"/>
+                    </a:solidFill>
+                  </a:tcPr>
+                </a:tc>
+              </a:tr>
+            </a:tbl>
+          </a:graphicData>
+        </a:graphic>
+      </p:graphicFrame>
+      <p:sp>
+        <p:nvSpPr>
+          <p:cNvPr id="20" name="Text 17"/>
+          <p:cNvSpPr/>
+          <p:nvPr/>
+        </p:nvSpPr>
+        <p:spPr>
+          <a:xfrm>
+            <a:off x="10067544" y="5148072"/>
+            <a:ext cx="1280160" cy="228600"/>
           </a:xfrm>
           <a:prstGeom prst="rect">
             <a:avLst/>
@@ -6116,11 +9023,50 @@
           <a:bodyPr wrap="square" rtlCol="0" anchor="ctr"/>
           <a:lstStyle/>
           <a:p>
+            <a:pPr algn="r" indent="0" marL="0">
+              <a:buNone/>
+            </a:pPr>
+            <a:r>
+              <a:rPr lang="en-US" sz="900" i="1" dirty="0">
+                <a:solidFill>
+                  <a:srgbClr val="9AA5B5"/>
+                </a:solidFill>
+                <a:latin typeface="Calibri" pitchFamily="34" charset="0"/>
+                <a:ea typeface="Calibri" pitchFamily="34" charset="-122"/>
+                <a:cs typeface="Calibri" pitchFamily="34" charset="-120"/>
+              </a:rPr>
+              <a:t>Sample report</a:t>
+            </a:r>
+            <a:endParaRPr lang="en-US" sz="900" dirty="0"/>
+          </a:p>
+        </p:txBody>
+      </p:sp>
+      <p:sp>
+        <p:nvSpPr>
+          <p:cNvPr id="21" name="Text 18"/>
+          <p:cNvSpPr/>
+          <p:nvPr/>
+        </p:nvSpPr>
+        <p:spPr>
+          <a:xfrm>
+            <a:off x="566928" y="5586984"/>
+            <a:ext cx="11064240" cy="457200"/>
+          </a:xfrm>
+          <a:prstGeom prst="rect">
+            <a:avLst/>
+          </a:prstGeom>
+          <a:noFill/>
+          <a:ln/>
+        </p:spPr>
+        <p:txBody>
+          <a:bodyPr wrap="square" rtlCol="0" anchor="ctr"/>
+          <a:lstStyle/>
+          <a:p>
             <a:pPr indent="0" marL="0">
               <a:buNone/>
             </a:pPr>
             <a:r>
-              <a:rPr lang="en-US" sz="1500" b="1" dirty="0">
+              <a:rPr lang="en-US" sz="1400" b="1" dirty="0">
                 <a:solidFill>
                   <a:srgbClr val="2563EB"/>
                 </a:solidFill>
@@ -6134,7 +9080,7 @@
               <a:buNone/>
             </a:pPr>
             <a:r>
-              <a:rPr lang="en-US" sz="1500" dirty="0">
+              <a:rPr lang="en-US" sz="1400" dirty="0">
                 <a:solidFill>
                   <a:srgbClr val="5B6B85"/>
                 </a:solidFill>
@@ -6142,115 +9088,9 @@
                 <a:ea typeface="Calibri" pitchFamily="34" charset="-122"/>
                 <a:cs typeface="Calibri" pitchFamily="34" charset="-120"/>
               </a:rPr>
-              <a:t>One report per release — grouped by module, worst first.</a:t>
-            </a:r>
-            <a:endParaRPr lang="en-US" sz="1500" dirty="0"/>
-          </a:p>
-        </p:txBody>
-      </p:sp>
-      <p:sp>
-        <p:nvSpPr>
-          <p:cNvPr id="17" name="Text 15"/>
-          <p:cNvSpPr/>
-          <p:nvPr/>
-        </p:nvSpPr>
-        <p:spPr>
-          <a:xfrm>
-            <a:off x="566928" y="4544568"/>
-            <a:ext cx="10972800" cy="457200"/>
-          </a:xfrm>
-          <a:prstGeom prst="rect">
-            <a:avLst/>
-          </a:prstGeom>
-          <a:noFill/>
-          <a:ln/>
-        </p:spPr>
-        <p:txBody>
-          <a:bodyPr wrap="square" rtlCol="0" anchor="ctr"/>
-          <a:lstStyle/>
-          <a:p>
-            <a:pPr indent="0" marL="0">
-              <a:buNone/>
-            </a:pPr>
-            <a:r>
-              <a:rPr lang="en-US" sz="1500" b="1" dirty="0">
-                <a:solidFill>
-                  <a:srgbClr val="2563EB"/>
-                </a:solidFill>
-                <a:latin typeface="Calibri" pitchFamily="34" charset="0"/>
-                <a:ea typeface="Calibri" pitchFamily="34" charset="-122"/>
-                <a:cs typeface="Calibri" pitchFamily="34" charset="-120"/>
-              </a:rPr>
-              <a:t>→   </a:t>
-            </a:r>
-            <a:pPr indent="0" marL="0">
-              <a:buNone/>
-            </a:pPr>
-            <a:r>
-              <a:rPr lang="en-US" sz="1500" dirty="0">
-                <a:solidFill>
-                  <a:srgbClr val="5B6B85"/>
-                </a:solidFill>
-                <a:latin typeface="Calibri" pitchFamily="34" charset="0"/>
-                <a:ea typeface="Calibri" pitchFamily="34" charset="-122"/>
-                <a:cs typeface="Calibri" pitchFamily="34" charset="-120"/>
-              </a:rPr>
-              <a:t>Each module shows tested / not tested / issues, with a clear status.</a:t>
-            </a:r>
-            <a:endParaRPr lang="en-US" sz="1500" dirty="0"/>
-          </a:p>
-        </p:txBody>
-      </p:sp>
-      <p:sp>
-        <p:nvSpPr>
-          <p:cNvPr id="18" name="Text 16"/>
-          <p:cNvSpPr/>
-          <p:nvPr/>
-        </p:nvSpPr>
-        <p:spPr>
-          <a:xfrm>
-            <a:off x="566928" y="5111496"/>
-            <a:ext cx="10972800" cy="457200"/>
-          </a:xfrm>
-          <a:prstGeom prst="rect">
-            <a:avLst/>
-          </a:prstGeom>
-          <a:noFill/>
-          <a:ln/>
-        </p:spPr>
-        <p:txBody>
-          <a:bodyPr wrap="square" rtlCol="0" anchor="ctr"/>
-          <a:lstStyle/>
-          <a:p>
-            <a:pPr indent="0" marL="0">
-              <a:buNone/>
-            </a:pPr>
-            <a:r>
-              <a:rPr lang="en-US" sz="1500" b="1" dirty="0">
-                <a:solidFill>
-                  <a:srgbClr val="2563EB"/>
-                </a:solidFill>
-                <a:latin typeface="Calibri" pitchFamily="34" charset="0"/>
-                <a:ea typeface="Calibri" pitchFamily="34" charset="-122"/>
-                <a:cs typeface="Calibri" pitchFamily="34" charset="-120"/>
-              </a:rPr>
-              <a:t>→   </a:t>
-            </a:r>
-            <a:pPr indent="0" marL="0">
-              <a:buNone/>
-            </a:pPr>
-            <a:r>
-              <a:rPr lang="en-US" sz="1500" dirty="0">
-                <a:solidFill>
-                  <a:srgbClr val="5B6B85"/>
-                </a:solidFill>
-                <a:latin typeface="Calibri" pitchFamily="34" charset="0"/>
-                <a:ea typeface="Calibri" pitchFamily="34" charset="-122"/>
-                <a:cs typeface="Calibri" pitchFamily="34" charset="-120"/>
-              </a:rPr>
-              <a:t>A shareable PDF — release sign-off from a single document.</a:t>
-            </a:r>
-            <a:endParaRPr lang="en-US" sz="1500" dirty="0"/>
+              <a:t>One shareable PDF — modules worst-first, each with tested / not-tested / issues and a Ready · Review · At-risk status.</a:t>
+            </a:r>
+            <a:endParaRPr lang="en-US" sz="1400" dirty="0"/>
           </a:p>
         </p:txBody>
       </p:sp>

</xml_diff>